<commit_message>
Update submission PPT with ASCII architecture diagram and corrected architecture summary.
EOF
</commit_message>
<xml_diff>
--- a/SubmissionDocument/Enterprise_Knowledge_Assistant_Vivek_kumar.pptx
+++ b/SubmissionDocument/Enterprise_Knowledge_Assistant_Vivek_kumar.pptx
@@ -10,10 +10,17 @@
     <p:sldId id="258" r:id="rId4"/>
     <p:sldId id="259" r:id="rId5"/>
     <p:sldId id="260" r:id="rId6"/>
-    <p:sldId id="264" r:id="rId7"/>
-    <p:sldId id="266" r:id="rId8"/>
-    <p:sldId id="270" r:id="rId9"/>
-    <p:sldId id="271" r:id="rId10"/>
+    <p:sldId id="261" r:id="rId7"/>
+    <p:sldId id="262" r:id="rId8"/>
+    <p:sldId id="263" r:id="rId9"/>
+    <p:sldId id="264" r:id="rId10"/>
+    <p:sldId id="265" r:id="rId11"/>
+    <p:sldId id="266" r:id="rId12"/>
+    <p:sldId id="267" r:id="rId13"/>
+    <p:sldId id="268" r:id="rId14"/>
+    <p:sldId id="269" r:id="rId15"/>
+    <p:sldId id="271" r:id="rId16"/>
+    <p:sldId id="272" r:id="rId17"/>
   </p:sldIdLst>
   <p:sldSz cx="9144000" cy="6858000" type="screen4x3"/>
   <p:notesSz cx="6858000" cy="9144000"/>
@@ -312,7 +319,7 @@
           <a:p>
             <a:fld id="{5BCAD085-E8A6-8845-BD4E-CB4CCA059FC4}" type="datetimeFigureOut">
               <a:rPr lang="en-US" smtClean="0"/>
-              <a:t>9/11/2026</a:t>
+              <a:t>9/13/2026</a:t>
             </a:fld>
             <a:endParaRPr lang="en-US"/>
           </a:p>
@@ -482,7 +489,7 @@
           <a:p>
             <a:fld id="{5BCAD085-E8A6-8845-BD4E-CB4CCA059FC4}" type="datetimeFigureOut">
               <a:rPr lang="en-US" smtClean="0"/>
-              <a:t>9/11/2026</a:t>
+              <a:t>9/13/2026</a:t>
             </a:fld>
             <a:endParaRPr lang="en-US"/>
           </a:p>
@@ -662,7 +669,7 @@
           <a:p>
             <a:fld id="{5BCAD085-E8A6-8845-BD4E-CB4CCA059FC4}" type="datetimeFigureOut">
               <a:rPr lang="en-US" smtClean="0"/>
-              <a:t>9/11/2026</a:t>
+              <a:t>9/13/2026</a:t>
             </a:fld>
             <a:endParaRPr lang="en-US"/>
           </a:p>
@@ -832,7 +839,7 @@
           <a:p>
             <a:fld id="{5BCAD085-E8A6-8845-BD4E-CB4CCA059FC4}" type="datetimeFigureOut">
               <a:rPr lang="en-US" smtClean="0"/>
-              <a:t>9/11/2026</a:t>
+              <a:t>9/13/2026</a:t>
             </a:fld>
             <a:endParaRPr lang="en-US"/>
           </a:p>
@@ -1078,7 +1085,7 @@
           <a:p>
             <a:fld id="{5BCAD085-E8A6-8845-BD4E-CB4CCA059FC4}" type="datetimeFigureOut">
               <a:rPr lang="en-US" smtClean="0"/>
-              <a:t>9/11/2026</a:t>
+              <a:t>9/13/2026</a:t>
             </a:fld>
             <a:endParaRPr lang="en-US"/>
           </a:p>
@@ -1366,7 +1373,7 @@
           <a:p>
             <a:fld id="{5BCAD085-E8A6-8845-BD4E-CB4CCA059FC4}" type="datetimeFigureOut">
               <a:rPr lang="en-US" smtClean="0"/>
-              <a:t>9/11/2026</a:t>
+              <a:t>9/13/2026</a:t>
             </a:fld>
             <a:endParaRPr lang="en-US"/>
           </a:p>
@@ -1788,7 +1795,7 @@
           <a:p>
             <a:fld id="{5BCAD085-E8A6-8845-BD4E-CB4CCA059FC4}" type="datetimeFigureOut">
               <a:rPr lang="en-US" smtClean="0"/>
-              <a:t>9/11/2026</a:t>
+              <a:t>9/13/2026</a:t>
             </a:fld>
             <a:endParaRPr lang="en-US"/>
           </a:p>
@@ -1906,7 +1913,7 @@
           <a:p>
             <a:fld id="{5BCAD085-E8A6-8845-BD4E-CB4CCA059FC4}" type="datetimeFigureOut">
               <a:rPr lang="en-US" smtClean="0"/>
-              <a:t>9/11/2026</a:t>
+              <a:t>9/13/2026</a:t>
             </a:fld>
             <a:endParaRPr lang="en-US"/>
           </a:p>
@@ -2001,7 +2008,7 @@
           <a:p>
             <a:fld id="{5BCAD085-E8A6-8845-BD4E-CB4CCA059FC4}" type="datetimeFigureOut">
               <a:rPr lang="en-US" smtClean="0"/>
-              <a:t>9/11/2026</a:t>
+              <a:t>9/13/2026</a:t>
             </a:fld>
             <a:endParaRPr lang="en-US"/>
           </a:p>
@@ -2278,7 +2285,7 @@
           <a:p>
             <a:fld id="{5BCAD085-E8A6-8845-BD4E-CB4CCA059FC4}" type="datetimeFigureOut">
               <a:rPr lang="en-US" smtClean="0"/>
-              <a:t>9/11/2026</a:t>
+              <a:t>9/13/2026</a:t>
             </a:fld>
             <a:endParaRPr lang="en-US"/>
           </a:p>
@@ -2531,7 +2538,7 @@
           <a:p>
             <a:fld id="{5BCAD085-E8A6-8845-BD4E-CB4CCA059FC4}" type="datetimeFigureOut">
               <a:rPr lang="en-US" smtClean="0"/>
-              <a:t>9/11/2026</a:t>
+              <a:t>9/13/2026</a:t>
             </a:fld>
             <a:endParaRPr lang="en-US"/>
           </a:p>
@@ -2744,7 +2751,7 @@
           <a:p>
             <a:fld id="{5BCAD085-E8A6-8845-BD4E-CB4CCA059FC4}" type="datetimeFigureOut">
               <a:rPr lang="en-US" smtClean="0"/>
-              <a:t>9/11/2026</a:t>
+              <a:t>9/13/2026</a:t>
             </a:fld>
             <a:endParaRPr lang="en-US"/>
           </a:p>
@@ -3170,7 +3177,7 @@
         </p:nvSpPr>
         <p:spPr>
           <a:xfrm>
-            <a:off x="1296844" y="2522064"/>
+            <a:off x="1530109" y="3291840"/>
             <a:ext cx="6083781" cy="954107"/>
           </a:xfrm>
           <a:prstGeom prst="rect">
@@ -3198,12 +3205,16 @@
           </a:p>
           <a:p>
             <a:r>
-              <a:rPr lang="en-US" dirty="0" smtClean="0"/>
-              <a:t>    </a:t>
+              <a:rPr dirty="0" err="1"/>
+              <a:t>Vivek</a:t>
+            </a:r>
+            <a:r>
+              <a:rPr dirty="0"/>
+              <a:t> Kumar | IIT Patna </a:t>
             </a:r>
             <a:r>
               <a:rPr dirty="0" err="1" smtClean="0"/>
-              <a:t>Vivek</a:t>
+              <a:t>GenAI</a:t>
             </a:r>
             <a:r>
               <a:rPr dirty="0" smtClean="0"/>
@@ -3211,25 +3222,216 @@
             </a:r>
             <a:r>
               <a:rPr dirty="0"/>
-              <a:t>Kumar | IIT Patna USDC </a:t>
-            </a:r>
+              <a:t>Development Program</a:t>
+            </a:r>
+          </a:p>
+          <a:p>
             <a:r>
               <a:rPr dirty="0" err="1"/>
-              <a:t>GenAI</a:t>
+              <a:t>Oeeggis</a:t>
             </a:r>
             <a:r>
               <a:rPr dirty="0"/>
-              <a:t> Development Program</a:t>
-            </a:r>
-          </a:p>
-          <a:p>
+              <a:t> Corporation (Fictional — Academic Project)</a:t>
+            </a:r>
+          </a:p>
+        </p:txBody>
+      </p:sp>
+    </p:spTree>
+  </p:cSld>
+  <p:clrMapOvr>
+    <a:masterClrMapping/>
+  </p:clrMapOvr>
+</p:sld>
+</file>
+
+<file path=ppt/slides/slide10.xml><?xml version="1.0" encoding="utf-8"?>
+<p:sld xmlns:a="http://schemas.openxmlformats.org/drawingml/2006/main" xmlns:r="http://schemas.openxmlformats.org/officeDocument/2006/relationships" xmlns:p="http://schemas.openxmlformats.org/presentationml/2006/main">
+  <p:cSld>
+    <p:spTree>
+      <p:nvGrpSpPr>
+        <p:cNvPr id="1" name=""/>
+        <p:cNvGrpSpPr/>
+        <p:nvPr/>
+      </p:nvGrpSpPr>
+      <p:grpSpPr>
+        <a:xfrm>
+          <a:off x="0" y="0"/>
+          <a:ext cx="0" cy="0"/>
+          <a:chOff x="0" y="0"/>
+          <a:chExt cx="0" cy="0"/>
+        </a:xfrm>
+      </p:grpSpPr>
+      <p:sp>
+        <p:nvSpPr>
+          <p:cNvPr id="2" name="TextBox 1"/>
+          <p:cNvSpPr txBox="1"/>
+          <p:nvPr/>
+        </p:nvSpPr>
+        <p:spPr>
+          <a:xfrm>
+            <a:off x="457200" y="228600"/>
+            <a:ext cx="8229600" cy="548640"/>
+          </a:xfrm>
+          <a:prstGeom prst="rect">
+            <a:avLst/>
+          </a:prstGeom>
+          <a:noFill/>
+        </p:spPr>
+        <p:txBody>
+          <a:bodyPr wrap="none">
+            <a:spAutoFit/>
+          </a:bodyPr>
+          <a:lstStyle/>
+          <a:p>
+            <a:pPr>
+              <a:defRPr sz="2800" b="1">
+                <a:solidFill>
+                  <a:srgbClr val="1565C0"/>
+                </a:solidFill>
+              </a:defRPr>
+            </a:pPr>
+            <a:r>
+              <a:t>Application UI — Home Screen</a:t>
+            </a:r>
+          </a:p>
+        </p:txBody>
+      </p:sp>
+      <p:pic>
+        <p:nvPicPr>
+          <p:cNvPr id="3" name="Picture 2" descr="app_home_screen.png"/>
+          <p:cNvPicPr>
+            <a:picLocks noChangeAspect="1"/>
+          </p:cNvPicPr>
+          <p:nvPr/>
+        </p:nvPicPr>
+        <p:blipFill>
+          <a:blip r:embed="rId2"/>
+          <a:stretch>
+            <a:fillRect/>
+          </a:stretch>
+        </p:blipFill>
+        <p:spPr>
+          <a:xfrm>
+            <a:off x="411480" y="868680"/>
+            <a:ext cx="5394960" cy="2671137"/>
+          </a:xfrm>
+          <a:prstGeom prst="rect">
+            <a:avLst/>
+          </a:prstGeom>
+        </p:spPr>
+      </p:pic>
+      <p:sp>
+        <p:nvSpPr>
+          <p:cNvPr id="4" name="TextBox 3"/>
+          <p:cNvSpPr txBox="1"/>
+          <p:nvPr/>
+        </p:nvSpPr>
+        <p:spPr>
+          <a:xfrm>
+            <a:off x="261256" y="3770500"/>
+            <a:ext cx="8425543" cy="1123384"/>
+          </a:xfrm>
+          <a:prstGeom prst="rect">
+            <a:avLst/>
+          </a:prstGeom>
+          <a:noFill/>
+        </p:spPr>
+        <p:txBody>
+          <a:bodyPr wrap="square">
+            <a:spAutoFit/>
+          </a:bodyPr>
+          <a:lstStyle/>
+          <a:p>
+            <a:pPr>
+              <a:spcAft>
+                <a:spcPts val="600"/>
+              </a:spcAft>
+              <a:defRPr sz="1300">
+                <a:solidFill>
+                  <a:srgbClr val="1F2937"/>
+                </a:solidFill>
+              </a:defRPr>
+            </a:pPr>
+            <a:r>
+              <a:rPr dirty="0"/>
+              <a:t>Header: </a:t>
+            </a:r>
+            <a:r>
+              <a:rPr dirty="0" err="1"/>
+              <a:t>Oeeggis</a:t>
+            </a:r>
+            <a:r>
+              <a:rPr dirty="0"/>
+              <a:t> Corporation branding and app </a:t>
+            </a:r>
+            <a:r>
+              <a:rPr dirty="0" smtClean="0"/>
+              <a:t>title.</a:t>
+            </a:r>
             <a:r>
               <a:rPr lang="en-US" dirty="0" smtClean="0"/>
-              <a:t>   </a:t>
+              <a:t> </a:t>
+            </a:r>
+            <a:r>
+              <a:rPr dirty="0" smtClean="0"/>
+              <a:t>Sidebar </a:t>
+            </a:r>
+            <a:r>
+              <a:rPr dirty="0"/>
+              <a:t>— Knowledge Scope lists all indexed policy documents.</a:t>
+            </a:r>
+          </a:p>
+          <a:p>
+            <a:pPr>
+              <a:spcAft>
+                <a:spcPts val="600"/>
+              </a:spcAft>
+              <a:defRPr sz="1300">
+                <a:solidFill>
+                  <a:srgbClr val="1F2937"/>
+                </a:solidFill>
+              </a:defRPr>
+            </a:pPr>
+            <a:r>
+              <a:rPr dirty="0"/>
+              <a:t>User can see which topics the assistant can answer from</a:t>
+            </a:r>
+            <a:r>
+              <a:rPr dirty="0" smtClean="0"/>
+              <a:t>.</a:t>
+            </a:r>
+            <a:r>
+              <a:rPr lang="en-US" dirty="0" smtClean="0"/>
+              <a:t> </a:t>
+            </a:r>
+            <a:r>
+              <a:rPr dirty="0" smtClean="0"/>
+              <a:t>Main </a:t>
+            </a:r>
+            <a:r>
+              <a:rPr dirty="0"/>
+              <a:t>chat area shows welcome message from the assistant.</a:t>
+            </a:r>
+          </a:p>
+          <a:p>
+            <a:pPr>
+              <a:spcAft>
+                <a:spcPts val="600"/>
+              </a:spcAft>
+              <a:defRPr sz="1300">
+                <a:solidFill>
+                  <a:srgbClr val="1F2937"/>
+                </a:solidFill>
+              </a:defRPr>
+            </a:pPr>
+            <a:r>
+              <a:rPr dirty="0"/>
+              <a:t>Chat input at bottom: type policy questions in natural </a:t>
             </a:r>
             <a:r>
               <a:rPr dirty="0" err="1" smtClean="0"/>
-              <a:t>Oeeggis</a:t>
+              <a:t>language.Clear</a:t>
             </a:r>
             <a:r>
               <a:rPr dirty="0" smtClean="0"/>
@@ -3237,7 +3439,1079 @@
             </a:r>
             <a:r>
               <a:rPr dirty="0"/>
-              <a:t>Corporation (Fictional — Academic Project)</a:t>
+              <a:t>/ Reset button clears chat history and memory.</a:t>
+            </a:r>
+          </a:p>
+          <a:p>
+            <a:pPr>
+              <a:spcAft>
+                <a:spcPts val="600"/>
+              </a:spcAft>
+              <a:defRPr sz="1300">
+                <a:solidFill>
+                  <a:srgbClr val="1F2937"/>
+                </a:solidFill>
+              </a:defRPr>
+            </a:pPr>
+            <a:r>
+              <a:rPr dirty="0"/>
+              <a:t>Footer disclaimer: academic/fictional company notice</a:t>
+            </a:r>
+            <a:r>
+              <a:rPr dirty="0" smtClean="0"/>
+              <a:t>.</a:t>
+            </a:r>
+            <a:r>
+              <a:rPr lang="en-US" dirty="0" smtClean="0"/>
+              <a:t> </a:t>
+            </a:r>
+            <a:endParaRPr dirty="0"/>
+          </a:p>
+        </p:txBody>
+      </p:sp>
+    </p:spTree>
+  </p:cSld>
+  <p:clrMapOvr>
+    <a:masterClrMapping/>
+  </p:clrMapOvr>
+</p:sld>
+</file>
+
+<file path=ppt/slides/slide11.xml><?xml version="1.0" encoding="utf-8"?>
+<p:sld xmlns:a="http://schemas.openxmlformats.org/drawingml/2006/main" xmlns:r="http://schemas.openxmlformats.org/officeDocument/2006/relationships" xmlns:p="http://schemas.openxmlformats.org/presentationml/2006/main">
+  <p:cSld>
+    <p:spTree>
+      <p:nvGrpSpPr>
+        <p:cNvPr id="1" name=""/>
+        <p:cNvGrpSpPr/>
+        <p:nvPr/>
+      </p:nvGrpSpPr>
+      <p:grpSpPr>
+        <a:xfrm>
+          <a:off x="0" y="0"/>
+          <a:ext cx="0" cy="0"/>
+          <a:chOff x="0" y="0"/>
+          <a:chExt cx="0" cy="0"/>
+        </a:xfrm>
+      </p:grpSpPr>
+      <p:sp>
+        <p:nvSpPr>
+          <p:cNvPr id="2" name="TextBox 1"/>
+          <p:cNvSpPr txBox="1"/>
+          <p:nvPr/>
+        </p:nvSpPr>
+        <p:spPr>
+          <a:xfrm>
+            <a:off x="457200" y="320040"/>
+            <a:ext cx="8229600" cy="731520"/>
+          </a:xfrm>
+          <a:prstGeom prst="rect">
+            <a:avLst/>
+          </a:prstGeom>
+          <a:noFill/>
+        </p:spPr>
+        <p:txBody>
+          <a:bodyPr wrap="none">
+            <a:spAutoFit/>
+          </a:bodyPr>
+          <a:lstStyle/>
+          <a:p>
+            <a:pPr>
+              <a:defRPr sz="3000" b="1">
+                <a:solidFill>
+                  <a:srgbClr val="1565C0"/>
+                </a:solidFill>
+              </a:defRPr>
+            </a:pPr>
+            <a:r>
+              <a:t>UI Functionality Explained</a:t>
+            </a:r>
+          </a:p>
+        </p:txBody>
+      </p:sp>
+      <p:sp>
+        <p:nvSpPr>
+          <p:cNvPr id="3" name="TextBox 2"/>
+          <p:cNvSpPr txBox="1"/>
+          <p:nvPr/>
+        </p:nvSpPr>
+        <p:spPr>
+          <a:xfrm>
+            <a:off x="640080" y="1097280"/>
+            <a:ext cx="8046720" cy="5303520"/>
+          </a:xfrm>
+          <a:prstGeom prst="rect">
+            <a:avLst/>
+          </a:prstGeom>
+          <a:noFill/>
+        </p:spPr>
+        <p:txBody>
+          <a:bodyPr wrap="none">
+            <a:spAutoFit/>
+          </a:bodyPr>
+          <a:lstStyle/>
+          <a:p>
+            <a:pPr>
+              <a:spcAft>
+                <a:spcPts val="800"/>
+              </a:spcAft>
+              <a:defRPr sz="1800">
+                <a:solidFill>
+                  <a:srgbClr val="1F2937"/>
+                </a:solidFill>
+              </a:defRPr>
+            </a:pPr>
+            <a:r>
+              <a:t>Knowledge Scope (sidebar): all 7 documents are searchable.</a:t>
+            </a:r>
+          </a:p>
+          <a:p>
+            <a:pPr>
+              <a:spcAft>
+                <a:spcPts val="800"/>
+              </a:spcAft>
+              <a:defRPr sz="1800">
+                <a:solidFill>
+                  <a:srgbClr val="1F2937"/>
+                </a:solidFill>
+              </a:defRPr>
+            </a:pPr>
+            <a:r>
+              <a:t>Chat interaction: ask HR, IT, travel, leave, and benefits questions.</a:t>
+            </a:r>
+          </a:p>
+          <a:p>
+            <a:pPr>
+              <a:spcAft>
+                <a:spcPts val="800"/>
+              </a:spcAft>
+              <a:defRPr sz="1800">
+                <a:solidFill>
+                  <a:srgbClr val="1F2937"/>
+                </a:solidFill>
+              </a:defRPr>
+            </a:pPr>
+            <a:r>
+              <a:t>Conversation history: previous messages stay visible in the chat.</a:t>
+            </a:r>
+          </a:p>
+          <a:p>
+            <a:pPr>
+              <a:spcAft>
+                <a:spcPts val="800"/>
+              </a:spcAft>
+              <a:defRPr sz="1800">
+                <a:solidFill>
+                  <a:srgbClr val="1F2937"/>
+                </a:solidFill>
+              </a:defRPr>
+            </a:pPr>
+            <a:r>
+              <a:t>Source citations: policy answers show document names below reply.</a:t>
+            </a:r>
+          </a:p>
+          <a:p>
+            <a:pPr>
+              <a:spcAft>
+                <a:spcPts val="800"/>
+              </a:spcAft>
+              <a:defRPr sz="1800">
+                <a:solidFill>
+                  <a:srgbClr val="1F2937"/>
+                </a:solidFill>
+              </a:defRPr>
+            </a:pPr>
+            <a:r>
+              <a:t>Follow-up support: e.g. 'What about carry-forward?' after leave policy.</a:t>
+            </a:r>
+          </a:p>
+          <a:p>
+            <a:pPr>
+              <a:spcAft>
+                <a:spcPts val="800"/>
+              </a:spcAft>
+              <a:defRPr sz="1800">
+                <a:solidFill>
+                  <a:srgbClr val="1F2937"/>
+                </a:solidFill>
+              </a:defRPr>
+            </a:pPr>
+            <a:r>
+              <a:t>Intro handling: casual messages get quick replies without policy search.</a:t>
+            </a:r>
+          </a:p>
+          <a:p>
+            <a:pPr>
+              <a:spcAft>
+                <a:spcPts val="800"/>
+              </a:spcAft>
+              <a:defRPr sz="1800">
+                <a:solidFill>
+                  <a:srgbClr val="1F2937"/>
+                </a:solidFill>
+              </a:defRPr>
+            </a:pPr>
+            <a:r>
+              <a:t>Hallucination guard: returns not-found message when data is missing.</a:t>
+            </a:r>
+          </a:p>
+          <a:p>
+            <a:pPr>
+              <a:spcAft>
+                <a:spcPts val="800"/>
+              </a:spcAft>
+              <a:defRPr sz="1800">
+                <a:solidFill>
+                  <a:srgbClr val="1F2937"/>
+                </a:solidFill>
+              </a:defRPr>
+            </a:pPr>
+            <a:r>
+              <a:t>Clear / Reset: starts a fresh session for a new conversation.</a:t>
+            </a:r>
+          </a:p>
+        </p:txBody>
+      </p:sp>
+    </p:spTree>
+  </p:cSld>
+  <p:clrMapOvr>
+    <a:masterClrMapping/>
+  </p:clrMapOvr>
+</p:sld>
+</file>
+
+<file path=ppt/slides/slide12.xml><?xml version="1.0" encoding="utf-8"?>
+<p:sld xmlns:a="http://schemas.openxmlformats.org/drawingml/2006/main" xmlns:r="http://schemas.openxmlformats.org/officeDocument/2006/relationships" xmlns:p="http://schemas.openxmlformats.org/presentationml/2006/main">
+  <p:cSld>
+    <p:spTree>
+      <p:nvGrpSpPr>
+        <p:cNvPr id="1" name=""/>
+        <p:cNvGrpSpPr/>
+        <p:nvPr/>
+      </p:nvGrpSpPr>
+      <p:grpSpPr>
+        <a:xfrm>
+          <a:off x="0" y="0"/>
+          <a:ext cx="0" cy="0"/>
+          <a:chOff x="0" y="0"/>
+          <a:chExt cx="0" cy="0"/>
+        </a:xfrm>
+      </p:grpSpPr>
+      <p:sp>
+        <p:nvSpPr>
+          <p:cNvPr id="2" name="TextBox 1"/>
+          <p:cNvSpPr txBox="1"/>
+          <p:nvPr/>
+        </p:nvSpPr>
+        <p:spPr>
+          <a:xfrm>
+            <a:off x="457200" y="320040"/>
+            <a:ext cx="8229600" cy="731520"/>
+          </a:xfrm>
+          <a:prstGeom prst="rect">
+            <a:avLst/>
+          </a:prstGeom>
+          <a:noFill/>
+        </p:spPr>
+        <p:txBody>
+          <a:bodyPr wrap="none">
+            <a:spAutoFit/>
+          </a:bodyPr>
+          <a:lstStyle/>
+          <a:p>
+            <a:pPr>
+              <a:defRPr sz="3000" b="1">
+                <a:solidFill>
+                  <a:srgbClr val="1565C0"/>
+                </a:solidFill>
+              </a:defRPr>
+            </a:pPr>
+            <a:r>
+              <a:t>Demo Flow</a:t>
+            </a:r>
+          </a:p>
+        </p:txBody>
+      </p:sp>
+      <p:sp>
+        <p:nvSpPr>
+          <p:cNvPr id="3" name="TextBox 2"/>
+          <p:cNvSpPr txBox="1"/>
+          <p:nvPr/>
+        </p:nvSpPr>
+        <p:spPr>
+          <a:xfrm>
+            <a:off x="640080" y="1097280"/>
+            <a:ext cx="4904548" cy="1887696"/>
+          </a:xfrm>
+          <a:prstGeom prst="rect">
+            <a:avLst/>
+          </a:prstGeom>
+          <a:noFill/>
+        </p:spPr>
+        <p:txBody>
+          <a:bodyPr wrap="none">
+            <a:spAutoFit/>
+          </a:bodyPr>
+          <a:lstStyle/>
+          <a:p>
+            <a:pPr>
+              <a:spcAft>
+                <a:spcPts val="800"/>
+              </a:spcAft>
+              <a:defRPr sz="1800">
+                <a:solidFill>
+                  <a:srgbClr val="1F2937"/>
+                </a:solidFill>
+              </a:defRPr>
+            </a:pPr>
+            <a:r>
+              <a:rPr dirty="0"/>
+              <a:t>1. Run setup.bat and python scripts/ingest.py</a:t>
+            </a:r>
+          </a:p>
+          <a:p>
+            <a:pPr>
+              <a:spcAft>
+                <a:spcPts val="800"/>
+              </a:spcAft>
+              <a:defRPr sz="1800">
+                <a:solidFill>
+                  <a:srgbClr val="1F2937"/>
+                </a:solidFill>
+              </a:defRPr>
+            </a:pPr>
+            <a:r>
+              <a:rPr dirty="0"/>
+              <a:t>2. Start app with start.bat → http://localhost:8501</a:t>
+            </a:r>
+          </a:p>
+          <a:p>
+            <a:pPr>
+              <a:spcAft>
+                <a:spcPts val="800"/>
+              </a:spcAft>
+              <a:defRPr sz="1800">
+                <a:solidFill>
+                  <a:srgbClr val="1F2937"/>
+                </a:solidFill>
+              </a:defRPr>
+            </a:pPr>
+            <a:r>
+              <a:rPr dirty="0"/>
+              <a:t>3. Ask: What is the leave policy?</a:t>
+            </a:r>
+          </a:p>
+          <a:p>
+            <a:pPr>
+              <a:spcAft>
+                <a:spcPts val="800"/>
+              </a:spcAft>
+              <a:defRPr sz="1800">
+                <a:solidFill>
+                  <a:srgbClr val="1F2937"/>
+                </a:solidFill>
+              </a:defRPr>
+            </a:pPr>
+            <a:r>
+              <a:rPr dirty="0"/>
+              <a:t>4. Follow-up: What about carry-forward?</a:t>
+            </a:r>
+          </a:p>
+          <a:p>
+            <a:pPr>
+              <a:spcAft>
+                <a:spcPts val="800"/>
+              </a:spcAft>
+              <a:defRPr sz="1800">
+                <a:solidFill>
+                  <a:srgbClr val="1F2937"/>
+                </a:solidFill>
+              </a:defRPr>
+            </a:pPr>
+            <a:endParaRPr dirty="0"/>
+          </a:p>
+        </p:txBody>
+      </p:sp>
+    </p:spTree>
+  </p:cSld>
+  <p:clrMapOvr>
+    <a:masterClrMapping/>
+  </p:clrMapOvr>
+</p:sld>
+</file>
+
+<file path=ppt/slides/slide13.xml><?xml version="1.0" encoding="utf-8"?>
+<p:sld xmlns:a="http://schemas.openxmlformats.org/drawingml/2006/main" xmlns:r="http://schemas.openxmlformats.org/officeDocument/2006/relationships" xmlns:p="http://schemas.openxmlformats.org/presentationml/2006/main">
+  <p:cSld>
+    <p:spTree>
+      <p:nvGrpSpPr>
+        <p:cNvPr id="1" name=""/>
+        <p:cNvGrpSpPr/>
+        <p:nvPr/>
+      </p:nvGrpSpPr>
+      <p:grpSpPr>
+        <a:xfrm>
+          <a:off x="0" y="0"/>
+          <a:ext cx="0" cy="0"/>
+          <a:chOff x="0" y="0"/>
+          <a:chExt cx="0" cy="0"/>
+        </a:xfrm>
+      </p:grpSpPr>
+      <p:sp>
+        <p:nvSpPr>
+          <p:cNvPr id="2" name="TextBox 1"/>
+          <p:cNvSpPr txBox="1"/>
+          <p:nvPr/>
+        </p:nvSpPr>
+        <p:spPr>
+          <a:xfrm>
+            <a:off x="457200" y="320040"/>
+            <a:ext cx="8229600" cy="731520"/>
+          </a:xfrm>
+          <a:prstGeom prst="rect">
+            <a:avLst/>
+          </a:prstGeom>
+          <a:noFill/>
+        </p:spPr>
+        <p:txBody>
+          <a:bodyPr wrap="none">
+            <a:spAutoFit/>
+          </a:bodyPr>
+          <a:lstStyle/>
+          <a:p>
+            <a:pPr>
+              <a:defRPr sz="3000" b="1">
+                <a:solidFill>
+                  <a:srgbClr val="1565C0"/>
+                </a:solidFill>
+              </a:defRPr>
+            </a:pPr>
+            <a:r>
+              <a:t>Sample Output</a:t>
+            </a:r>
+          </a:p>
+        </p:txBody>
+      </p:sp>
+      <p:sp>
+        <p:nvSpPr>
+          <p:cNvPr id="3" name="TextBox 2"/>
+          <p:cNvSpPr txBox="1"/>
+          <p:nvPr/>
+        </p:nvSpPr>
+        <p:spPr>
+          <a:xfrm>
+            <a:off x="640080" y="1097280"/>
+            <a:ext cx="6038448" cy="3406061"/>
+          </a:xfrm>
+          <a:prstGeom prst="rect">
+            <a:avLst/>
+          </a:prstGeom>
+          <a:noFill/>
+        </p:spPr>
+        <p:txBody>
+          <a:bodyPr wrap="none">
+            <a:spAutoFit/>
+          </a:bodyPr>
+          <a:lstStyle/>
+          <a:p>
+            <a:pPr>
+              <a:spcAft>
+                <a:spcPts val="800"/>
+              </a:spcAft>
+              <a:defRPr sz="1800">
+                <a:solidFill>
+                  <a:srgbClr val="1F2937"/>
+                </a:solidFill>
+              </a:defRPr>
+            </a:pPr>
+            <a:r>
+              <a:rPr dirty="0"/>
+              <a:t>Q: What is the leave policy?</a:t>
+            </a:r>
+          </a:p>
+          <a:p>
+            <a:pPr>
+              <a:spcAft>
+                <a:spcPts val="800"/>
+              </a:spcAft>
+              <a:defRPr sz="1800">
+                <a:solidFill>
+                  <a:srgbClr val="1F2937"/>
+                </a:solidFill>
+              </a:defRPr>
+            </a:pPr>
+            <a:r>
+              <a:rPr dirty="0"/>
+              <a:t>A: Summary from leave policy documents.</a:t>
+            </a:r>
+          </a:p>
+          <a:p>
+            <a:pPr>
+              <a:spcAft>
+                <a:spcPts val="800"/>
+              </a:spcAft>
+              <a:defRPr sz="1800">
+                <a:solidFill>
+                  <a:srgbClr val="1F2937"/>
+                </a:solidFill>
+              </a:defRPr>
+            </a:pPr>
+            <a:r>
+              <a:rPr dirty="0"/>
+              <a:t>Sources: Leave_Policy.pdf</a:t>
+            </a:r>
+          </a:p>
+          <a:p>
+            <a:pPr>
+              <a:spcAft>
+                <a:spcPts val="800"/>
+              </a:spcAft>
+              <a:defRPr sz="1800">
+                <a:solidFill>
+                  <a:srgbClr val="1F2937"/>
+                </a:solidFill>
+              </a:defRPr>
+            </a:pPr>
+            <a:endParaRPr dirty="0"/>
+          </a:p>
+          <a:p>
+            <a:pPr>
+              <a:spcAft>
+                <a:spcPts val="800"/>
+              </a:spcAft>
+              <a:defRPr sz="1800">
+                <a:solidFill>
+                  <a:srgbClr val="1F2937"/>
+                </a:solidFill>
+              </a:defRPr>
+            </a:pPr>
+            <a:r>
+              <a:rPr dirty="0"/>
+              <a:t>Q: What is the salary for the CEO?</a:t>
+            </a:r>
+          </a:p>
+          <a:p>
+            <a:pPr>
+              <a:spcAft>
+                <a:spcPts val="800"/>
+              </a:spcAft>
+              <a:defRPr sz="1800">
+                <a:solidFill>
+                  <a:srgbClr val="1F2937"/>
+                </a:solidFill>
+              </a:defRPr>
+            </a:pPr>
+            <a:r>
+              <a:rPr dirty="0"/>
+              <a:t>A: I could not find this information in the available documents.</a:t>
+            </a:r>
+          </a:p>
+          <a:p>
+            <a:pPr>
+              <a:spcAft>
+                <a:spcPts val="800"/>
+              </a:spcAft>
+              <a:defRPr sz="1800">
+                <a:solidFill>
+                  <a:srgbClr val="1F2937"/>
+                </a:solidFill>
+              </a:defRPr>
+            </a:pPr>
+            <a:endParaRPr dirty="0"/>
+          </a:p>
+          <a:p>
+            <a:pPr>
+              <a:spcAft>
+                <a:spcPts val="800"/>
+              </a:spcAft>
+              <a:defRPr sz="1800">
+                <a:solidFill>
+                  <a:srgbClr val="1F2937"/>
+                </a:solidFill>
+              </a:defRPr>
+            </a:pPr>
+            <a:r>
+              <a:rPr dirty="0"/>
+              <a:t>Q: Hi, my name is </a:t>
+            </a:r>
+            <a:r>
+              <a:rPr lang="en-US" dirty="0" err="1" smtClean="0"/>
+              <a:t>vivek</a:t>
+            </a:r>
+            <a:r>
+              <a:rPr lang="en-US" dirty="0" smtClean="0"/>
+              <a:t> </a:t>
+            </a:r>
+            <a:r>
+              <a:rPr dirty="0" smtClean="0"/>
+              <a:t> </a:t>
+            </a:r>
+            <a:r>
+              <a:rPr dirty="0"/>
+              <a:t>from Bangalore.</a:t>
+            </a:r>
+          </a:p>
+          <a:p>
+            <a:pPr>
+              <a:spcAft>
+                <a:spcPts val="800"/>
+              </a:spcAft>
+              <a:defRPr sz="1800">
+                <a:solidFill>
+                  <a:srgbClr val="1F2937"/>
+                </a:solidFill>
+              </a:defRPr>
+            </a:pPr>
+            <a:r>
+              <a:rPr dirty="0"/>
+              <a:t>A: Brief acknowledgement without unsolicited policy advice.</a:t>
+            </a:r>
+          </a:p>
+        </p:txBody>
+      </p:sp>
+    </p:spTree>
+  </p:cSld>
+  <p:clrMapOvr>
+    <a:masterClrMapping/>
+  </p:clrMapOvr>
+</p:sld>
+</file>
+
+<file path=ppt/slides/slide14.xml><?xml version="1.0" encoding="utf-8"?>
+<p:sld xmlns:a="http://schemas.openxmlformats.org/drawingml/2006/main" xmlns:r="http://schemas.openxmlformats.org/officeDocument/2006/relationships" xmlns:p="http://schemas.openxmlformats.org/presentationml/2006/main">
+  <p:cSld>
+    <p:spTree>
+      <p:nvGrpSpPr>
+        <p:cNvPr id="1" name=""/>
+        <p:cNvGrpSpPr/>
+        <p:nvPr/>
+      </p:nvGrpSpPr>
+      <p:grpSpPr>
+        <a:xfrm>
+          <a:off x="0" y="0"/>
+          <a:ext cx="0" cy="0"/>
+          <a:chOff x="0" y="0"/>
+          <a:chExt cx="0" cy="0"/>
+        </a:xfrm>
+      </p:grpSpPr>
+      <p:sp>
+        <p:nvSpPr>
+          <p:cNvPr id="2" name="TextBox 1"/>
+          <p:cNvSpPr txBox="1"/>
+          <p:nvPr/>
+        </p:nvSpPr>
+        <p:spPr>
+          <a:xfrm>
+            <a:off x="457200" y="320040"/>
+            <a:ext cx="8229600" cy="731520"/>
+          </a:xfrm>
+          <a:prstGeom prst="rect">
+            <a:avLst/>
+          </a:prstGeom>
+          <a:noFill/>
+        </p:spPr>
+        <p:txBody>
+          <a:bodyPr wrap="none">
+            <a:spAutoFit/>
+          </a:bodyPr>
+          <a:lstStyle/>
+          <a:p>
+            <a:pPr>
+              <a:defRPr sz="3000" b="1">
+                <a:solidFill>
+                  <a:srgbClr val="1565C0"/>
+                </a:solidFill>
+              </a:defRPr>
+            </a:pPr>
+            <a:r>
+              <a:t>Key Design Decisions</a:t>
+            </a:r>
+          </a:p>
+        </p:txBody>
+      </p:sp>
+      <p:sp>
+        <p:nvSpPr>
+          <p:cNvPr id="3" name="TextBox 2"/>
+          <p:cNvSpPr txBox="1"/>
+          <p:nvPr/>
+        </p:nvSpPr>
+        <p:spPr>
+          <a:xfrm>
+            <a:off x="640080" y="1097280"/>
+            <a:ext cx="8046720" cy="5303520"/>
+          </a:xfrm>
+          <a:prstGeom prst="rect">
+            <a:avLst/>
+          </a:prstGeom>
+          <a:noFill/>
+        </p:spPr>
+        <p:txBody>
+          <a:bodyPr wrap="none">
+            <a:spAutoFit/>
+          </a:bodyPr>
+          <a:lstStyle/>
+          <a:p>
+            <a:pPr>
+              <a:spcAft>
+                <a:spcPts val="800"/>
+              </a:spcAft>
+              <a:defRPr sz="1800">
+                <a:solidFill>
+                  <a:srgbClr val="1F2937"/>
+                </a:solidFill>
+              </a:defRPr>
+            </a:pPr>
+            <a:r>
+              <a:t>Hybrid retrieval combines semantic meaning and exact keyword matches.</a:t>
+            </a:r>
+          </a:p>
+          <a:p>
+            <a:pPr>
+              <a:spcAft>
+                <a:spcPts val="800"/>
+              </a:spcAft>
+              <a:defRPr sz="1800">
+                <a:solidFill>
+                  <a:srgbClr val="1F2937"/>
+                </a:solidFill>
+              </a:defRPr>
+            </a:pPr>
+            <a:r>
+              <a:t>Reranking improves precision before sending context to the LLM.</a:t>
+            </a:r>
+          </a:p>
+          <a:p>
+            <a:pPr>
+              <a:spcAft>
+                <a:spcPts val="800"/>
+              </a:spcAft>
+              <a:defRPr sz="1800">
+                <a:solidFill>
+                  <a:srgbClr val="1F2937"/>
+                </a:solidFill>
+              </a:defRPr>
+            </a:pPr>
+            <a:r>
+              <a:t>Conversational routing skips document search for casual introductions.</a:t>
+            </a:r>
+          </a:p>
+          <a:p>
+            <a:pPr>
+              <a:spcAft>
+                <a:spcPts val="800"/>
+              </a:spcAft>
+              <a:defRPr sz="1800">
+                <a:solidFill>
+                  <a:srgbClr val="1F2937"/>
+                </a:solidFill>
+              </a:defRPr>
+            </a:pPr>
+            <a:r>
+              <a:t>Models preload at startup to reduce first-question delay.</a:t>
+            </a:r>
+          </a:p>
+          <a:p>
+            <a:pPr>
+              <a:spcAft>
+                <a:spcPts val="800"/>
+              </a:spcAft>
+              <a:defRPr sz="1800">
+                <a:solidFill>
+                  <a:srgbClr val="1F2937"/>
+                </a:solidFill>
+              </a:defRPr>
+            </a:pPr>
+            <a:r>
+              <a:t>Modular layers: ingestion, retrieval, generation, and app UI.</a:t>
+            </a:r>
+          </a:p>
+        </p:txBody>
+      </p:sp>
+    </p:spTree>
+  </p:cSld>
+  <p:clrMapOvr>
+    <a:masterClrMapping/>
+  </p:clrMapOvr>
+</p:sld>
+</file>
+
+<file path=ppt/slides/slide15.xml><?xml version="1.0" encoding="utf-8"?>
+<p:sld xmlns:a="http://schemas.openxmlformats.org/drawingml/2006/main" xmlns:r="http://schemas.openxmlformats.org/officeDocument/2006/relationships" xmlns:p="http://schemas.openxmlformats.org/presentationml/2006/main">
+  <p:cSld>
+    <p:spTree>
+      <p:nvGrpSpPr>
+        <p:cNvPr id="1" name=""/>
+        <p:cNvGrpSpPr/>
+        <p:nvPr/>
+      </p:nvGrpSpPr>
+      <p:grpSpPr>
+        <a:xfrm>
+          <a:off x="0" y="0"/>
+          <a:ext cx="0" cy="0"/>
+          <a:chOff x="0" y="0"/>
+          <a:chExt cx="0" cy="0"/>
+        </a:xfrm>
+      </p:grpSpPr>
+      <p:sp>
+        <p:nvSpPr>
+          <p:cNvPr id="2" name="TextBox 1"/>
+          <p:cNvSpPr txBox="1"/>
+          <p:nvPr/>
+        </p:nvSpPr>
+        <p:spPr>
+          <a:xfrm>
+            <a:off x="457200" y="320040"/>
+            <a:ext cx="8229600" cy="731520"/>
+          </a:xfrm>
+          <a:prstGeom prst="rect">
+            <a:avLst/>
+          </a:prstGeom>
+          <a:noFill/>
+        </p:spPr>
+        <p:txBody>
+          <a:bodyPr wrap="none">
+            <a:spAutoFit/>
+          </a:bodyPr>
+          <a:lstStyle/>
+          <a:p>
+            <a:pPr>
+              <a:defRPr sz="3000" b="1">
+                <a:solidFill>
+                  <a:srgbClr val="1565C0"/>
+                </a:solidFill>
+              </a:defRPr>
+            </a:pPr>
+            <a:r>
+              <a:t>How to Run</a:t>
+            </a:r>
+          </a:p>
+        </p:txBody>
+      </p:sp>
+      <p:sp>
+        <p:nvSpPr>
+          <p:cNvPr id="3" name="TextBox 2"/>
+          <p:cNvSpPr txBox="1"/>
+          <p:nvPr/>
+        </p:nvSpPr>
+        <p:spPr>
+          <a:xfrm>
+            <a:off x="640080" y="1097280"/>
+            <a:ext cx="8046720" cy="5303520"/>
+          </a:xfrm>
+          <a:prstGeom prst="rect">
+            <a:avLst/>
+          </a:prstGeom>
+          <a:noFill/>
+        </p:spPr>
+        <p:txBody>
+          <a:bodyPr wrap="none">
+            <a:spAutoFit/>
+          </a:bodyPr>
+          <a:lstStyle/>
+          <a:p>
+            <a:pPr>
+              <a:spcAft>
+                <a:spcPts val="800"/>
+              </a:spcAft>
+              <a:defRPr sz="1800">
+                <a:solidFill>
+                  <a:srgbClr val="1F2937"/>
+                </a:solidFill>
+              </a:defRPr>
+            </a:pPr>
+            <a:r>
+              <a:t>1. setup.bat (first time only)</a:t>
+            </a:r>
+          </a:p>
+          <a:p>
+            <a:pPr>
+              <a:spcAft>
+                <a:spcPts val="800"/>
+              </a:spcAft>
+              <a:defRPr sz="1800">
+                <a:solidFill>
+                  <a:srgbClr val="1F2937"/>
+                </a:solidFill>
+              </a:defRPr>
+            </a:pPr>
+            <a:r>
+              <a:t>2. copy .env.example .env and add OPENAI_API_KEY</a:t>
+            </a:r>
+          </a:p>
+          <a:p>
+            <a:pPr>
+              <a:spcAft>
+                <a:spcPts val="800"/>
+              </a:spcAft>
+              <a:defRPr sz="1800">
+                <a:solidFill>
+                  <a:srgbClr val="1F2937"/>
+                </a:solidFill>
+              </a:defRPr>
+            </a:pPr>
+            <a:r>
+              <a:t>3. python scripts/ingest.py</a:t>
+            </a:r>
+          </a:p>
+          <a:p>
+            <a:pPr>
+              <a:spcAft>
+                <a:spcPts val="800"/>
+              </a:spcAft>
+              <a:defRPr sz="1800">
+                <a:solidFill>
+                  <a:srgbClr val="1F2937"/>
+                </a:solidFill>
+              </a:defRPr>
+            </a:pPr>
+            <a:r>
+              <a:t>4. start.bat</a:t>
+            </a:r>
+          </a:p>
+          <a:p>
+            <a:pPr>
+              <a:spcAft>
+                <a:spcPts val="800"/>
+              </a:spcAft>
+              <a:defRPr sz="1800">
+                <a:solidFill>
+                  <a:srgbClr val="1F2937"/>
+                </a:solidFill>
+              </a:defRPr>
+            </a:pPr>
+            <a:r>
+              <a:t>5. Open http://localhost:8501</a:t>
+            </a:r>
+          </a:p>
+          <a:p>
+            <a:pPr>
+              <a:spcAft>
+                <a:spcPts val="800"/>
+              </a:spcAft>
+              <a:defRPr sz="1800">
+                <a:solidFill>
+                  <a:srgbClr val="1F2937"/>
+                </a:solidFill>
+              </a:defRPr>
+            </a:pPr>
+            <a:r>
+              <a:t>Submission docs available in SubmissionDocument/ folder.</a:t>
+            </a:r>
+          </a:p>
+        </p:txBody>
+      </p:sp>
+    </p:spTree>
+  </p:cSld>
+  <p:clrMapOvr>
+    <a:masterClrMapping/>
+  </p:clrMapOvr>
+</p:sld>
+</file>
+
+<file path=ppt/slides/slide16.xml><?xml version="1.0" encoding="utf-8"?>
+<p:sld xmlns:a="http://schemas.openxmlformats.org/drawingml/2006/main" xmlns:r="http://schemas.openxmlformats.org/officeDocument/2006/relationships" xmlns:p="http://schemas.openxmlformats.org/presentationml/2006/main">
+  <p:cSld>
+    <p:bg>
+      <p:bgPr>
+        <a:solidFill>
+          <a:srgbClr val="1565C0"/>
+        </a:solidFill>
+        <a:effectLst/>
+      </p:bgPr>
+    </p:bg>
+    <p:spTree>
+      <p:nvGrpSpPr>
+        <p:cNvPr id="1" name=""/>
+        <p:cNvGrpSpPr/>
+        <p:nvPr/>
+      </p:nvGrpSpPr>
+      <p:grpSpPr>
+        <a:xfrm>
+          <a:off x="0" y="0"/>
+          <a:ext cx="0" cy="0"/>
+          <a:chOff x="0" y="0"/>
+          <a:chExt cx="0" cy="0"/>
+        </a:xfrm>
+      </p:grpSpPr>
+      <p:sp>
+        <p:nvSpPr>
+          <p:cNvPr id="2" name="TextBox 1"/>
+          <p:cNvSpPr txBox="1"/>
+          <p:nvPr/>
+        </p:nvSpPr>
+        <p:spPr>
+          <a:xfrm>
+            <a:off x="640080" y="1828800"/>
+            <a:ext cx="7863840" cy="1371600"/>
+          </a:xfrm>
+          <a:prstGeom prst="rect">
+            <a:avLst/>
+          </a:prstGeom>
+          <a:noFill/>
+        </p:spPr>
+        <p:txBody>
+          <a:bodyPr wrap="none">
+            <a:spAutoFit/>
+          </a:bodyPr>
+          <a:lstStyle/>
+          <a:p>
+            <a:pPr algn="ctr">
+              <a:defRPr sz="3600" b="1">
+                <a:solidFill>
+                  <a:srgbClr val="FFFFFF"/>
+                </a:solidFill>
+              </a:defRPr>
+            </a:pPr>
+            <a:r>
+              <a:t>Thank You</a:t>
+            </a:r>
+          </a:p>
+        </p:txBody>
+      </p:sp>
+      <p:sp>
+        <p:nvSpPr>
+          <p:cNvPr id="3" name="TextBox 2"/>
+          <p:cNvSpPr txBox="1"/>
+          <p:nvPr/>
+        </p:nvSpPr>
+        <p:spPr>
+          <a:xfrm>
+            <a:off x="640080" y="3291840"/>
+            <a:ext cx="7863840" cy="1097280"/>
+          </a:xfrm>
+          <a:prstGeom prst="rect">
+            <a:avLst/>
+          </a:prstGeom>
+          <a:noFill/>
+        </p:spPr>
+        <p:txBody>
+          <a:bodyPr wrap="none">
+            <a:spAutoFit/>
+          </a:bodyPr>
+          <a:lstStyle/>
+          <a:p>
+            <a:pPr algn="ctr">
+              <a:defRPr sz="2000">
+                <a:solidFill>
+                  <a:srgbClr val="FFFFFF"/>
+                </a:solidFill>
+              </a:defRPr>
+            </a:pPr>
+            <a:r>
+              <a:t>Questions &amp; Discussion</a:t>
+            </a:r>
+          </a:p>
+          <a:p>
+            <a:endParaRPr/>
+          </a:p>
+          <a:p>
+            <a:r>
+              <a:t>Vivek Kumar</a:t>
+            </a:r>
+          </a:p>
+          <a:p>
+            <a:r>
+              <a:t>Enterprise Knowledge Assistant — Advanced RAG</a:t>
             </a:r>
           </a:p>
         </p:txBody>
@@ -3695,8 +4969,8 @@
         </p:nvSpPr>
         <p:spPr>
           <a:xfrm>
-            <a:off x="457200" y="320040"/>
-            <a:ext cx="8229600" cy="731520"/>
+            <a:off x="457200" y="137160"/>
+            <a:ext cx="8229600" cy="457200"/>
           </a:xfrm>
           <a:prstGeom prst="rect">
             <a:avLst/>
@@ -3710,14 +4984,14 @@
           <a:lstStyle/>
           <a:p>
             <a:pPr>
-              <a:defRPr sz="3000" b="1">
+              <a:defRPr sz="2600" b="1">
                 <a:solidFill>
                   <a:srgbClr val="1565C0"/>
                 </a:solidFill>
               </a:defRPr>
             </a:pPr>
             <a:r>
-              <a:t>Architecture Summary</a:t>
+              <a:t>High-Level Architecture (ASCII)</a:t>
             </a:r>
           </a:p>
         </p:txBody>
@@ -3730,8 +5004,8 @@
         </p:nvSpPr>
         <p:spPr>
           <a:xfrm>
-            <a:off x="640080" y="1097280"/>
-            <a:ext cx="7844712" cy="1887696"/>
+            <a:off x="228600" y="594360"/>
+            <a:ext cx="8686800" cy="6126480"/>
           </a:xfrm>
           <a:prstGeom prst="rect">
             <a:avLst/>
@@ -3745,122 +5019,838 @@
           <a:lstStyle/>
           <a:p>
             <a:pPr>
-              <a:spcAft>
-                <a:spcPts val="800"/>
-              </a:spcAft>
-              <a:defRPr sz="1800">
-                <a:solidFill>
-                  <a:srgbClr val="1F2937"/>
-                </a:solidFill>
-              </a:defRPr>
-            </a:pPr>
-            <a:r>
-              <a:rPr dirty="0"/>
-              <a:t>Indexing: Documents → Loader → </a:t>
-            </a:r>
-            <a:r>
-              <a:rPr dirty="0" err="1"/>
-              <a:t>Chunker</a:t>
-            </a:r>
-            <a:r>
-              <a:rPr dirty="0"/>
-              <a:t> → </a:t>
-            </a:r>
-            <a:r>
-              <a:rPr dirty="0" err="1"/>
-              <a:t>Embeddings</a:t>
-            </a:r>
-            <a:r>
-              <a:rPr dirty="0"/>
-              <a:t> → </a:t>
-            </a:r>
-            <a:r>
-              <a:rPr dirty="0" err="1"/>
-              <a:t>ChromaDB</a:t>
-            </a:r>
-            <a:r>
-              <a:rPr dirty="0"/>
-              <a:t> + BM25.</a:t>
-            </a:r>
-          </a:p>
-          <a:p>
-            <a:pPr>
-              <a:spcAft>
-                <a:spcPts val="800"/>
-              </a:spcAft>
-              <a:defRPr sz="1800">
-                <a:solidFill>
-                  <a:srgbClr val="1F2937"/>
-                </a:solidFill>
-              </a:defRPr>
-            </a:pPr>
-            <a:r>
-              <a:rPr dirty="0"/>
-              <a:t>Query: User input → route message → hybrid search → </a:t>
-            </a:r>
-            <a:r>
-              <a:rPr dirty="0" err="1"/>
-              <a:t>rerank</a:t>
-            </a:r>
-            <a:r>
-              <a:rPr dirty="0"/>
-              <a:t> → LLM.</a:t>
-            </a:r>
-          </a:p>
-          <a:p>
-            <a:pPr>
-              <a:spcAft>
-                <a:spcPts val="800"/>
-              </a:spcAft>
-              <a:defRPr sz="1800">
-                <a:solidFill>
-                  <a:srgbClr val="1F2937"/>
-                </a:solidFill>
-              </a:defRPr>
-            </a:pPr>
-            <a:r>
-              <a:rPr dirty="0"/>
-              <a:t>Memory rewrite handles follow-up questions using chat history.</a:t>
-            </a:r>
-          </a:p>
-          <a:p>
-            <a:pPr>
-              <a:spcAft>
-                <a:spcPts val="800"/>
-              </a:spcAft>
-              <a:defRPr sz="1800">
-                <a:solidFill>
-                  <a:srgbClr val="1F2937"/>
-                </a:solidFill>
-              </a:defRPr>
-            </a:pPr>
-            <a:r>
-              <a:rPr dirty="0"/>
-              <a:t>Instant reply path for greetings and casual introductions.</a:t>
-            </a:r>
-          </a:p>
-          <a:p>
-            <a:pPr>
-              <a:spcAft>
-                <a:spcPts val="800"/>
-              </a:spcAft>
-              <a:defRPr sz="1800">
-                <a:solidFill>
-                  <a:srgbClr val="1F2937"/>
-                </a:solidFill>
-              </a:defRPr>
-            </a:pPr>
-            <a:r>
-              <a:rPr dirty="0" err="1" smtClean="0"/>
-              <a:t>Streamlit</a:t>
-            </a:r>
-            <a:r>
-              <a:rPr dirty="0" smtClean="0"/>
-              <a:t> </a:t>
-            </a:r>
-            <a:r>
-              <a:rPr dirty="0"/>
-              <a:t>UI shows answer, sources, history, and reset option.</a:t>
+              <a:lnSpc>
+                <a:spcPct val="100000"/>
+              </a:lnSpc>
+              <a:spcAft>
+                <a:spcPts val="0"/>
+              </a:spcAft>
+              <a:defRPr sz="750">
+                <a:solidFill>
+                  <a:srgbClr val="1F2937"/>
+                </a:solidFill>
+                <a:latin typeface="Courier New"/>
+              </a:defRPr>
+            </a:pPr>
+            <a:r>
+              <a:t>Documents (PDF/TXT/DOCX)</a:t>
+            </a:r>
+          </a:p>
+          <a:p>
+            <a:pPr>
+              <a:lnSpc>
+                <a:spcPct val="100000"/>
+              </a:lnSpc>
+              <a:spcAft>
+                <a:spcPts val="0"/>
+              </a:spcAft>
+              <a:defRPr sz="750">
+                <a:solidFill>
+                  <a:srgbClr val="1F2937"/>
+                </a:solidFill>
+                <a:latin typeface="Courier New"/>
+              </a:defRPr>
+            </a:pPr>
+            <a:r>
+              <a:t>        |</a:t>
+            </a:r>
+          </a:p>
+          <a:p>
+            <a:pPr>
+              <a:lnSpc>
+                <a:spcPct val="100000"/>
+              </a:lnSpc>
+              <a:spcAft>
+                <a:spcPts val="0"/>
+              </a:spcAft>
+              <a:defRPr sz="750">
+                <a:solidFill>
+                  <a:srgbClr val="1F2937"/>
+                </a:solidFill>
+                <a:latin typeface="Courier New"/>
+              </a:defRPr>
+            </a:pPr>
+            <a:r>
+              <a:t>        v</a:t>
+            </a:r>
+          </a:p>
+          <a:p>
+            <a:pPr>
+              <a:lnSpc>
+                <a:spcPct val="100000"/>
+              </a:lnSpc>
+              <a:spcAft>
+                <a:spcPts val="0"/>
+              </a:spcAft>
+              <a:defRPr sz="750">
+                <a:solidFill>
+                  <a:srgbClr val="1F2937"/>
+                </a:solidFill>
+                <a:latin typeface="Courier New"/>
+              </a:defRPr>
+            </a:pPr>
+            <a:r>
+              <a:t>+-------------------+</a:t>
+            </a:r>
+          </a:p>
+          <a:p>
+            <a:pPr>
+              <a:lnSpc>
+                <a:spcPct val="100000"/>
+              </a:lnSpc>
+              <a:spcAft>
+                <a:spcPts val="0"/>
+              </a:spcAft>
+              <a:defRPr sz="750">
+                <a:solidFill>
+                  <a:srgbClr val="1F2937"/>
+                </a:solidFill>
+                <a:latin typeface="Courier New"/>
+              </a:defRPr>
+            </a:pPr>
+            <a:r>
+              <a:t>|  Document Loader  |  ingestion/loader.py</a:t>
+            </a:r>
+          </a:p>
+          <a:p>
+            <a:pPr>
+              <a:lnSpc>
+                <a:spcPct val="100000"/>
+              </a:lnSpc>
+              <a:spcAft>
+                <a:spcPts val="0"/>
+              </a:spcAft>
+              <a:defRPr sz="750">
+                <a:solidFill>
+                  <a:srgbClr val="1F2937"/>
+                </a:solidFill>
+                <a:latin typeface="Courier New"/>
+              </a:defRPr>
+            </a:pPr>
+            <a:r>
+              <a:t>+---------+---------+</a:t>
+            </a:r>
+          </a:p>
+          <a:p>
+            <a:pPr>
+              <a:lnSpc>
+                <a:spcPct val="100000"/>
+              </a:lnSpc>
+              <a:spcAft>
+                <a:spcPts val="0"/>
+              </a:spcAft>
+              <a:defRPr sz="750">
+                <a:solidFill>
+                  <a:srgbClr val="1F2937"/>
+                </a:solidFill>
+                <a:latin typeface="Courier New"/>
+              </a:defRPr>
+            </a:pPr>
+            <a:r>
+              <a:t>          v</a:t>
+            </a:r>
+          </a:p>
+          <a:p>
+            <a:pPr>
+              <a:lnSpc>
+                <a:spcPct val="100000"/>
+              </a:lnSpc>
+              <a:spcAft>
+                <a:spcPts val="0"/>
+              </a:spcAft>
+              <a:defRPr sz="750">
+                <a:solidFill>
+                  <a:srgbClr val="1F2937"/>
+                </a:solidFill>
+                <a:latin typeface="Courier New"/>
+              </a:defRPr>
+            </a:pPr>
+            <a:r>
+              <a:t>+-------------------+</a:t>
+            </a:r>
+          </a:p>
+          <a:p>
+            <a:pPr>
+              <a:lnSpc>
+                <a:spcPct val="100000"/>
+              </a:lnSpc>
+              <a:spcAft>
+                <a:spcPts val="0"/>
+              </a:spcAft>
+              <a:defRPr sz="750">
+                <a:solidFill>
+                  <a:srgbClr val="1F2937"/>
+                </a:solidFill>
+                <a:latin typeface="Courier New"/>
+              </a:defRPr>
+            </a:pPr>
+            <a:r>
+              <a:t>|     Chunker       |  ingestion/chunker.py</a:t>
+            </a:r>
+          </a:p>
+          <a:p>
+            <a:pPr>
+              <a:lnSpc>
+                <a:spcPct val="100000"/>
+              </a:lnSpc>
+              <a:spcAft>
+                <a:spcPts val="0"/>
+              </a:spcAft>
+              <a:defRPr sz="750">
+                <a:solidFill>
+                  <a:srgbClr val="1F2937"/>
+                </a:solidFill>
+                <a:latin typeface="Courier New"/>
+              </a:defRPr>
+            </a:pPr>
+            <a:r>
+              <a:t>+---------+---------+</a:t>
+            </a:r>
+          </a:p>
+          <a:p>
+            <a:pPr>
+              <a:lnSpc>
+                <a:spcPct val="100000"/>
+              </a:lnSpc>
+              <a:spcAft>
+                <a:spcPts val="0"/>
+              </a:spcAft>
+              <a:defRPr sz="750">
+                <a:solidFill>
+                  <a:srgbClr val="1F2937"/>
+                </a:solidFill>
+                <a:latin typeface="Courier New"/>
+              </a:defRPr>
+            </a:pPr>
+            <a:r>
+              <a:t>          v</a:t>
+            </a:r>
+          </a:p>
+          <a:p>
+            <a:pPr>
+              <a:lnSpc>
+                <a:spcPct val="100000"/>
+              </a:lnSpc>
+              <a:spcAft>
+                <a:spcPts val="0"/>
+              </a:spcAft>
+              <a:defRPr sz="750">
+                <a:solidFill>
+                  <a:srgbClr val="1F2937"/>
+                </a:solidFill>
+                <a:latin typeface="Courier New"/>
+              </a:defRPr>
+            </a:pPr>
+            <a:r>
+              <a:t>+-------------------+</a:t>
+            </a:r>
+          </a:p>
+          <a:p>
+            <a:pPr>
+              <a:lnSpc>
+                <a:spcPct val="100000"/>
+              </a:lnSpc>
+              <a:spcAft>
+                <a:spcPts val="0"/>
+              </a:spcAft>
+              <a:defRPr sz="750">
+                <a:solidFill>
+                  <a:srgbClr val="1F2937"/>
+                </a:solidFill>
+                <a:latin typeface="Courier New"/>
+              </a:defRPr>
+            </a:pPr>
+            <a:r>
+              <a:t>|   Embeddings      |  ingestion/embedder.py</a:t>
+            </a:r>
+          </a:p>
+          <a:p>
+            <a:pPr>
+              <a:lnSpc>
+                <a:spcPct val="100000"/>
+              </a:lnSpc>
+              <a:spcAft>
+                <a:spcPts val="0"/>
+              </a:spcAft>
+              <a:defRPr sz="750">
+                <a:solidFill>
+                  <a:srgbClr val="1F2937"/>
+                </a:solidFill>
+                <a:latin typeface="Courier New"/>
+              </a:defRPr>
+            </a:pPr>
+            <a:r>
+              <a:t>+---------+---------+</a:t>
+            </a:r>
+          </a:p>
+          <a:p>
+            <a:pPr>
+              <a:lnSpc>
+                <a:spcPct val="100000"/>
+              </a:lnSpc>
+              <a:spcAft>
+                <a:spcPts val="0"/>
+              </a:spcAft>
+              <a:defRPr sz="750">
+                <a:solidFill>
+                  <a:srgbClr val="1F2937"/>
+                </a:solidFill>
+                <a:latin typeface="Courier New"/>
+              </a:defRPr>
+            </a:pPr>
+            <a:r>
+              <a:t>          +----------------------+</a:t>
+            </a:r>
+          </a:p>
+          <a:p>
+            <a:pPr>
+              <a:lnSpc>
+                <a:spcPct val="100000"/>
+              </a:lnSpc>
+              <a:spcAft>
+                <a:spcPts val="0"/>
+              </a:spcAft>
+              <a:defRPr sz="750">
+                <a:solidFill>
+                  <a:srgbClr val="1F2937"/>
+                </a:solidFill>
+                <a:latin typeface="Courier New"/>
+              </a:defRPr>
+            </a:pPr>
+            <a:r>
+              <a:t>          v                      v</a:t>
+            </a:r>
+          </a:p>
+          <a:p>
+            <a:pPr>
+              <a:lnSpc>
+                <a:spcPct val="100000"/>
+              </a:lnSpc>
+              <a:spcAft>
+                <a:spcPts val="0"/>
+              </a:spcAft>
+              <a:defRPr sz="750">
+                <a:solidFill>
+                  <a:srgbClr val="1F2937"/>
+                </a:solidFill>
+                <a:latin typeface="Courier New"/>
+              </a:defRPr>
+            </a:pPr>
+            <a:r>
+              <a:t>+-------------------+    +-------------------+</a:t>
+            </a:r>
+          </a:p>
+          <a:p>
+            <a:pPr>
+              <a:lnSpc>
+                <a:spcPct val="100000"/>
+              </a:lnSpc>
+              <a:spcAft>
+                <a:spcPts val="0"/>
+              </a:spcAft>
+              <a:defRPr sz="750">
+                <a:solidFill>
+                  <a:srgbClr val="1F2937"/>
+                </a:solidFill>
+                <a:latin typeface="Courier New"/>
+              </a:defRPr>
+            </a:pPr>
+            <a:r>
+              <a:t>|  ChromaDB Vector  |    |    BM25 Index     |</a:t>
+            </a:r>
+          </a:p>
+          <a:p>
+            <a:pPr>
+              <a:lnSpc>
+                <a:spcPct val="100000"/>
+              </a:lnSpc>
+              <a:spcAft>
+                <a:spcPts val="0"/>
+              </a:spcAft>
+              <a:defRPr sz="750">
+                <a:solidFill>
+                  <a:srgbClr val="1F2937"/>
+                </a:solidFill>
+                <a:latin typeface="Courier New"/>
+              </a:defRPr>
+            </a:pPr>
+            <a:r>
+              <a:t>|      Store        |    |                   |</a:t>
+            </a:r>
+          </a:p>
+          <a:p>
+            <a:pPr>
+              <a:lnSpc>
+                <a:spcPct val="100000"/>
+              </a:lnSpc>
+              <a:spcAft>
+                <a:spcPts val="0"/>
+              </a:spcAft>
+              <a:defRPr sz="750">
+                <a:solidFill>
+                  <a:srgbClr val="1F2937"/>
+                </a:solidFill>
+                <a:latin typeface="Courier New"/>
+              </a:defRPr>
+            </a:pPr>
+            <a:r>
+              <a:t>+---------+---------+    +---------+---------+</a:t>
+            </a:r>
+          </a:p>
+          <a:p>
+            <a:pPr>
+              <a:lnSpc>
+                <a:spcPct val="100000"/>
+              </a:lnSpc>
+              <a:spcAft>
+                <a:spcPts val="0"/>
+              </a:spcAft>
+              <a:defRPr sz="750">
+                <a:solidFill>
+                  <a:srgbClr val="1F2937"/>
+                </a:solidFill>
+                <a:latin typeface="Courier New"/>
+              </a:defRPr>
+            </a:pPr>
+            <a:r>
+              <a:t>          |                        |</a:t>
+            </a:r>
+          </a:p>
+          <a:p>
+            <a:pPr>
+              <a:lnSpc>
+                <a:spcPct val="100000"/>
+              </a:lnSpc>
+              <a:spcAft>
+                <a:spcPts val="0"/>
+              </a:spcAft>
+              <a:defRPr sz="750">
+                <a:solidFill>
+                  <a:srgbClr val="1F2937"/>
+                </a:solidFill>
+                <a:latin typeface="Courier New"/>
+              </a:defRPr>
+            </a:pPr>
+            <a:r>
+              <a:t>          +------------+-----------+</a:t>
+            </a:r>
+          </a:p>
+          <a:p>
+            <a:pPr>
+              <a:lnSpc>
+                <a:spcPct val="100000"/>
+              </a:lnSpc>
+              <a:spcAft>
+                <a:spcPts val="0"/>
+              </a:spcAft>
+              <a:defRPr sz="750">
+                <a:solidFill>
+                  <a:srgbClr val="1F2937"/>
+                </a:solidFill>
+                <a:latin typeface="Courier New"/>
+              </a:defRPr>
+            </a:pPr>
+            <a:r>
+              <a:t>                       v</a:t>
+            </a:r>
+          </a:p>
+          <a:p>
+            <a:pPr>
+              <a:lnSpc>
+                <a:spcPct val="100000"/>
+              </a:lnSpc>
+              <a:spcAft>
+                <a:spcPts val="0"/>
+              </a:spcAft>
+              <a:defRPr sz="750">
+                <a:solidFill>
+                  <a:srgbClr val="1F2937"/>
+                </a:solidFill>
+                <a:latin typeface="Courier New"/>
+              </a:defRPr>
+            </a:pPr>
+            <a:r>
+              <a:t>            +-----------------------+</a:t>
+            </a:r>
+          </a:p>
+          <a:p>
+            <a:pPr>
+              <a:lnSpc>
+                <a:spcPct val="100000"/>
+              </a:lnSpc>
+              <a:spcAft>
+                <a:spcPts val="0"/>
+              </a:spcAft>
+              <a:defRPr sz="750">
+                <a:solidFill>
+                  <a:srgbClr val="1F2937"/>
+                </a:solidFill>
+                <a:latin typeface="Courier New"/>
+              </a:defRPr>
+            </a:pPr>
+            <a:r>
+              <a:t>            |   Hybrid Retriever    |  retrieval/hybrid_retriever.py</a:t>
+            </a:r>
+          </a:p>
+          <a:p>
+            <a:pPr>
+              <a:lnSpc>
+                <a:spcPct val="100000"/>
+              </a:lnSpc>
+              <a:spcAft>
+                <a:spcPts val="0"/>
+              </a:spcAft>
+              <a:defRPr sz="750">
+                <a:solidFill>
+                  <a:srgbClr val="1F2937"/>
+                </a:solidFill>
+                <a:latin typeface="Courier New"/>
+              </a:defRPr>
+            </a:pPr>
+            <a:r>
+              <a:t>            |   (Vector + BM25)     |</a:t>
+            </a:r>
+          </a:p>
+          <a:p>
+            <a:pPr>
+              <a:lnSpc>
+                <a:spcPct val="100000"/>
+              </a:lnSpc>
+              <a:spcAft>
+                <a:spcPts val="0"/>
+              </a:spcAft>
+              <a:defRPr sz="750">
+                <a:solidFill>
+                  <a:srgbClr val="1F2937"/>
+                </a:solidFill>
+                <a:latin typeface="Courier New"/>
+              </a:defRPr>
+            </a:pPr>
+            <a:r>
+              <a:t>            +-----------+-----------+</a:t>
+            </a:r>
+          </a:p>
+          <a:p>
+            <a:pPr>
+              <a:lnSpc>
+                <a:spcPct val="100000"/>
+              </a:lnSpc>
+              <a:spcAft>
+                <a:spcPts val="0"/>
+              </a:spcAft>
+              <a:defRPr sz="750">
+                <a:solidFill>
+                  <a:srgbClr val="1F2937"/>
+                </a:solidFill>
+                <a:latin typeface="Courier New"/>
+              </a:defRPr>
+            </a:pPr>
+            <a:r>
+              <a:t>                        v</a:t>
+            </a:r>
+          </a:p>
+          <a:p>
+            <a:pPr>
+              <a:lnSpc>
+                <a:spcPct val="100000"/>
+              </a:lnSpc>
+              <a:spcAft>
+                <a:spcPts val="0"/>
+              </a:spcAft>
+              <a:defRPr sz="750">
+                <a:solidFill>
+                  <a:srgbClr val="1F2937"/>
+                </a:solidFill>
+                <a:latin typeface="Courier New"/>
+              </a:defRPr>
+            </a:pPr>
+            <a:r>
+              <a:t>            +-----------------------+</a:t>
+            </a:r>
+          </a:p>
+          <a:p>
+            <a:pPr>
+              <a:lnSpc>
+                <a:spcPct val="100000"/>
+              </a:lnSpc>
+              <a:spcAft>
+                <a:spcPts val="0"/>
+              </a:spcAft>
+              <a:defRPr sz="750">
+                <a:solidFill>
+                  <a:srgbClr val="1F2937"/>
+                </a:solidFill>
+                <a:latin typeface="Courier New"/>
+              </a:defRPr>
+            </a:pPr>
+            <a:r>
+              <a:t>            |      Reranker         |  retrieval/reranker.py</a:t>
+            </a:r>
+          </a:p>
+          <a:p>
+            <a:pPr>
+              <a:lnSpc>
+                <a:spcPct val="100000"/>
+              </a:lnSpc>
+              <a:spcAft>
+                <a:spcPts val="0"/>
+              </a:spcAft>
+              <a:defRPr sz="750">
+                <a:solidFill>
+                  <a:srgbClr val="1F2937"/>
+                </a:solidFill>
+                <a:latin typeface="Courier New"/>
+              </a:defRPr>
+            </a:pPr>
+            <a:r>
+              <a:t>            +-----------+-----------+</a:t>
+            </a:r>
+          </a:p>
+          <a:p>
+            <a:pPr>
+              <a:lnSpc>
+                <a:spcPct val="100000"/>
+              </a:lnSpc>
+              <a:spcAft>
+                <a:spcPts val="0"/>
+              </a:spcAft>
+              <a:defRPr sz="750">
+                <a:solidFill>
+                  <a:srgbClr val="1F2937"/>
+                </a:solidFill>
+                <a:latin typeface="Courier New"/>
+              </a:defRPr>
+            </a:pPr>
+            <a:r>
+              <a:t>                        v</a:t>
+            </a:r>
+          </a:p>
+          <a:p>
+            <a:pPr>
+              <a:lnSpc>
+                <a:spcPct val="100000"/>
+              </a:lnSpc>
+              <a:spcAft>
+                <a:spcPts val="0"/>
+              </a:spcAft>
+              <a:defRPr sz="750">
+                <a:solidFill>
+                  <a:srgbClr val="1F2937"/>
+                </a:solidFill>
+                <a:latin typeface="Courier New"/>
+              </a:defRPr>
+            </a:pPr>
+            <a:r>
+              <a:t>            +-----------------------+</a:t>
+            </a:r>
+          </a:p>
+          <a:p>
+            <a:pPr>
+              <a:lnSpc>
+                <a:spcPct val="100000"/>
+              </a:lnSpc>
+              <a:spcAft>
+                <a:spcPts val="0"/>
+              </a:spcAft>
+              <a:defRPr sz="750">
+                <a:solidFill>
+                  <a:srgbClr val="1F2937"/>
+                </a:solidFill>
+                <a:latin typeface="Courier New"/>
+              </a:defRPr>
+            </a:pPr>
+            <a:r>
+              <a:t>            |   Context Builder     |  generation/guard.py</a:t>
+            </a:r>
+          </a:p>
+          <a:p>
+            <a:pPr>
+              <a:lnSpc>
+                <a:spcPct val="100000"/>
+              </a:lnSpc>
+              <a:spcAft>
+                <a:spcPts val="0"/>
+              </a:spcAft>
+              <a:defRPr sz="750">
+                <a:solidFill>
+                  <a:srgbClr val="1F2937"/>
+                </a:solidFill>
+                <a:latin typeface="Courier New"/>
+              </a:defRPr>
+            </a:pPr>
+            <a:r>
+              <a:t>            +-----------+-----------+</a:t>
+            </a:r>
+          </a:p>
+          <a:p>
+            <a:pPr>
+              <a:lnSpc>
+                <a:spcPct val="100000"/>
+              </a:lnSpc>
+              <a:spcAft>
+                <a:spcPts val="0"/>
+              </a:spcAft>
+              <a:defRPr sz="750">
+                <a:solidFill>
+                  <a:srgbClr val="1F2937"/>
+                </a:solidFill>
+                <a:latin typeface="Courier New"/>
+              </a:defRPr>
+            </a:pPr>
+            <a:r>
+              <a:t>                        v</a:t>
+            </a:r>
+          </a:p>
+          <a:p>
+            <a:pPr>
+              <a:lnSpc>
+                <a:spcPct val="100000"/>
+              </a:lnSpc>
+              <a:spcAft>
+                <a:spcPts val="0"/>
+              </a:spcAft>
+              <a:defRPr sz="750">
+                <a:solidFill>
+                  <a:srgbClr val="1F2937"/>
+                </a:solidFill>
+                <a:latin typeface="Courier New"/>
+              </a:defRPr>
+            </a:pPr>
+            <a:r>
+              <a:t>            +-----------------------+</a:t>
+            </a:r>
+          </a:p>
+          <a:p>
+            <a:pPr>
+              <a:lnSpc>
+                <a:spcPct val="100000"/>
+              </a:lnSpc>
+              <a:spcAft>
+                <a:spcPts val="0"/>
+              </a:spcAft>
+              <a:defRPr sz="750">
+                <a:solidFill>
+                  <a:srgbClr val="1F2937"/>
+                </a:solidFill>
+                <a:latin typeface="Courier New"/>
+              </a:defRPr>
+            </a:pPr>
+            <a:r>
+              <a:t>            |  LLM + Chat Memory    |  generation/chain.py</a:t>
+            </a:r>
+          </a:p>
+          <a:p>
+            <a:pPr>
+              <a:lnSpc>
+                <a:spcPct val="100000"/>
+              </a:lnSpc>
+              <a:spcAft>
+                <a:spcPts val="0"/>
+              </a:spcAft>
+              <a:defRPr sz="750">
+                <a:solidFill>
+                  <a:srgbClr val="1F2937"/>
+                </a:solidFill>
+                <a:latin typeface="Courier New"/>
+              </a:defRPr>
+            </a:pPr>
+            <a:r>
+              <a:t>            +-----------+-----------+</a:t>
+            </a:r>
+          </a:p>
+          <a:p>
+            <a:pPr>
+              <a:lnSpc>
+                <a:spcPct val="100000"/>
+              </a:lnSpc>
+              <a:spcAft>
+                <a:spcPts val="0"/>
+              </a:spcAft>
+              <a:defRPr sz="750">
+                <a:solidFill>
+                  <a:srgbClr val="1F2937"/>
+                </a:solidFill>
+                <a:latin typeface="Courier New"/>
+              </a:defRPr>
+            </a:pPr>
+            <a:r>
+              <a:t>                        v</a:t>
+            </a:r>
+          </a:p>
+          <a:p>
+            <a:pPr>
+              <a:lnSpc>
+                <a:spcPct val="100000"/>
+              </a:lnSpc>
+              <a:spcAft>
+                <a:spcPts val="0"/>
+              </a:spcAft>
+              <a:defRPr sz="750">
+                <a:solidFill>
+                  <a:srgbClr val="1F2937"/>
+                </a:solidFill>
+                <a:latin typeface="Courier New"/>
+              </a:defRPr>
+            </a:pPr>
+            <a:r>
+              <a:t>            +-----------------------+</a:t>
+            </a:r>
+          </a:p>
+          <a:p>
+            <a:pPr>
+              <a:lnSpc>
+                <a:spcPct val="100000"/>
+              </a:lnSpc>
+              <a:spcAft>
+                <a:spcPts val="0"/>
+              </a:spcAft>
+              <a:defRPr sz="750">
+                <a:solidFill>
+                  <a:srgbClr val="1F2937"/>
+                </a:solidFill>
+                <a:latin typeface="Courier New"/>
+              </a:defRPr>
+            </a:pPr>
+            <a:r>
+              <a:t>            |   Streamlit Chat UI   |  app/ui/chat.py</a:t>
+            </a:r>
+          </a:p>
+          <a:p>
+            <a:pPr>
+              <a:lnSpc>
+                <a:spcPct val="100000"/>
+              </a:lnSpc>
+              <a:spcAft>
+                <a:spcPts val="0"/>
+              </a:spcAft>
+              <a:defRPr sz="750">
+                <a:solidFill>
+                  <a:srgbClr val="1F2937"/>
+                </a:solidFill>
+                <a:latin typeface="Courier New"/>
+              </a:defRPr>
+            </a:pPr>
+            <a:r>
+              <a:t>            |  Answer + Sources     |</a:t>
+            </a:r>
+          </a:p>
+          <a:p>
+            <a:pPr>
+              <a:lnSpc>
+                <a:spcPct val="100000"/>
+              </a:lnSpc>
+              <a:spcAft>
+                <a:spcPts val="0"/>
+              </a:spcAft>
+              <a:defRPr sz="750">
+                <a:solidFill>
+                  <a:srgbClr val="1F2937"/>
+                </a:solidFill>
+                <a:latin typeface="Courier New"/>
+              </a:defRPr>
+            </a:pPr>
+            <a:r>
+              <a:t>            +-----------------------+</a:t>
             </a:r>
           </a:p>
         </p:txBody>
@@ -3898,8 +5888,8 @@
         </p:nvSpPr>
         <p:spPr>
           <a:xfrm>
-            <a:off x="457200" y="228600"/>
-            <a:ext cx="8229600" cy="548640"/>
+            <a:off x="457200" y="320040"/>
+            <a:ext cx="8229600" cy="731520"/>
           </a:xfrm>
           <a:prstGeom prst="rect">
             <a:avLst/>
@@ -3913,28 +5903,28 @@
           <a:lstStyle/>
           <a:p>
             <a:pPr>
-              <a:defRPr sz="2800" b="1">
+              <a:defRPr sz="3000" b="1">
                 <a:solidFill>
                   <a:srgbClr val="1565C0"/>
                 </a:solidFill>
               </a:defRPr>
             </a:pPr>
             <a:r>
-              <a:t>Application UI — Home Screen</a:t>
-            </a:r>
-          </a:p>
-        </p:txBody>
-      </p:sp>
-      <p:sp>
-        <p:nvSpPr>
-          <p:cNvPr id="4" name="TextBox 3"/>
+              <a:t>Architecture Summary</a:t>
+            </a:r>
+          </a:p>
+        </p:txBody>
+      </p:sp>
+      <p:sp>
+        <p:nvSpPr>
+          <p:cNvPr id="3" name="TextBox 2"/>
           <p:cNvSpPr txBox="1"/>
           <p:nvPr/>
         </p:nvSpPr>
         <p:spPr>
           <a:xfrm>
-            <a:off x="251927" y="5732727"/>
-            <a:ext cx="7847044" cy="692497"/>
+            <a:off x="640081" y="1097280"/>
+            <a:ext cx="8214670" cy="3477875"/>
           </a:xfrm>
           <a:prstGeom prst="rect">
             <a:avLst/>
@@ -3949,9 +5939,66 @@
           <a:p>
             <a:pPr>
               <a:spcAft>
-                <a:spcPts val="600"/>
-              </a:spcAft>
-              <a:defRPr sz="1300">
+                <a:spcPts val="800"/>
+              </a:spcAft>
+              <a:defRPr sz="1800">
+                <a:solidFill>
+                  <a:srgbClr val="1F2937"/>
+                </a:solidFill>
+              </a:defRPr>
+            </a:pPr>
+            <a:r>
+              <a:rPr dirty="0"/>
+              <a:t>Indexing: Documents → Loader → </a:t>
+            </a:r>
+            <a:r>
+              <a:rPr dirty="0" err="1"/>
+              <a:t>Chunker</a:t>
+            </a:r>
+            <a:r>
+              <a:rPr dirty="0"/>
+              <a:t> → </a:t>
+            </a:r>
+            <a:r>
+              <a:rPr dirty="0" err="1"/>
+              <a:t>Embeddings</a:t>
+            </a:r>
+            <a:r>
+              <a:rPr dirty="0"/>
+              <a:t> → </a:t>
+            </a:r>
+            <a:r>
+              <a:rPr dirty="0" err="1"/>
+              <a:t>ChromaDB</a:t>
+            </a:r>
+            <a:r>
+              <a:rPr dirty="0"/>
+              <a:t> + BM25.</a:t>
+            </a:r>
+          </a:p>
+          <a:p>
+            <a:pPr>
+              <a:spcAft>
+                <a:spcPts val="800"/>
+              </a:spcAft>
+              <a:defRPr sz="1800">
+                <a:solidFill>
+                  <a:srgbClr val="1F2937"/>
+                </a:solidFill>
+              </a:defRPr>
+            </a:pPr>
+            <a:r>
+              <a:rPr dirty="0"/>
+              <a:t>Query: </a:t>
+            </a:r>
+            <a:endParaRPr lang="en-US" dirty="0" smtClean="0"/>
+          </a:p>
+          <a:p>
+            <a:pPr>
+              <a:spcAft>
+                <a:spcPts val="800"/>
+              </a:spcAft>
+              <a:defRPr sz="1800">
                 <a:solidFill>
                   <a:srgbClr val="1F2937"/>
                 </a:solidFill>
@@ -3963,92 +6010,87 @@
             </a:r>
             <a:r>
               <a:rPr dirty="0"/>
-              <a:t>can see which topics the assistant can answer from</a:t>
-            </a:r>
-            <a:r>
-              <a:rPr dirty="0" smtClean="0"/>
-              <a:t>.</a:t>
-            </a:r>
-            <a:r>
-              <a:rPr lang="en-US" dirty="0" smtClean="0"/>
-              <a:t> </a:t>
-            </a:r>
-            <a:r>
-              <a:rPr dirty="0" smtClean="0"/>
-              <a:t>Main </a:t>
+              <a:t>input → route → memory rewrite → hybrid search → </a:t>
+            </a:r>
+            <a:r>
+              <a:rPr dirty="0" err="1"/>
+              <a:t>rerank</a:t>
             </a:r>
             <a:r>
               <a:rPr dirty="0"/>
-              <a:t>chat area shows welcome message from the </a:t>
-            </a:r>
-            <a:r>
-              <a:rPr dirty="0" smtClean="0"/>
-              <a:t>assistant.</a:t>
-            </a:r>
-            <a:r>
-              <a:rPr lang="en-US" dirty="0" smtClean="0"/>
-              <a:t> </a:t>
-            </a:r>
-            <a:r>
-              <a:rPr dirty="0" smtClean="0"/>
-              <a:t>Chat </a:t>
-            </a:r>
+              <a:t> → context builder → LLM.</a:t>
+            </a:r>
+          </a:p>
+          <a:p>
+            <a:pPr>
+              <a:spcAft>
+                <a:spcPts val="800"/>
+              </a:spcAft>
+              <a:defRPr sz="1800">
+                <a:solidFill>
+                  <a:srgbClr val="1F2937"/>
+                </a:solidFill>
+              </a:defRPr>
+            </a:pPr>
             <a:r>
               <a:rPr dirty="0"/>
-              <a:t>input at bottom: type policy questions in natural </a:t>
-            </a:r>
-            <a:r>
-              <a:rPr dirty="0" smtClean="0"/>
-              <a:t>language.</a:t>
-            </a:r>
-            <a:r>
-              <a:rPr lang="en-US" dirty="0" smtClean="0"/>
-              <a:t> </a:t>
-            </a:r>
-            <a:r>
-              <a:rPr dirty="0" smtClean="0"/>
-              <a:t>Clear </a:t>
-            </a:r>
+              <a:t>Routing: greetings (UI); casual intros and memory questions get instant replies without retrieval.</a:t>
+            </a:r>
+          </a:p>
+          <a:p>
+            <a:pPr>
+              <a:spcAft>
+                <a:spcPts val="800"/>
+              </a:spcAft>
+              <a:defRPr sz="1800">
+                <a:solidFill>
+                  <a:srgbClr val="1F2937"/>
+                </a:solidFill>
+              </a:defRPr>
+            </a:pPr>
             <a:r>
               <a:rPr dirty="0"/>
-              <a:t>/ Reset button clears chat history and memory</a:t>
-            </a:r>
-            <a:r>
-              <a:rPr dirty="0" smtClean="0"/>
-              <a:t>.</a:t>
-            </a:r>
-            <a:r>
-              <a:rPr lang="en-US" dirty="0" smtClean="0"/>
-              <a:t> </a:t>
-            </a:r>
-            <a:endParaRPr dirty="0"/>
-          </a:p>
-        </p:txBody>
-      </p:sp>
-      <p:pic>
-        <p:nvPicPr>
-          <p:cNvPr id="6" name="Picture 5"/>
-          <p:cNvPicPr>
-            <a:picLocks noChangeAspect="1"/>
-          </p:cNvPicPr>
-          <p:nvPr/>
-        </p:nvPicPr>
-        <p:blipFill>
-          <a:blip r:embed="rId2"/>
-          <a:stretch>
-            <a:fillRect/>
-          </a:stretch>
-        </p:blipFill>
-        <p:spPr>
-          <a:xfrm>
-            <a:off x="93308" y="685884"/>
-            <a:ext cx="8873836" cy="4697880"/>
-          </a:xfrm>
-          <a:prstGeom prst="rect">
-            <a:avLst/>
-          </a:prstGeom>
-        </p:spPr>
-      </p:pic>
+              <a:t>Policy questions run the full RAG pipeline and return answers with source citations.</a:t>
+            </a:r>
+          </a:p>
+          <a:p>
+            <a:pPr>
+              <a:spcAft>
+                <a:spcPts val="800"/>
+              </a:spcAft>
+              <a:defRPr sz="1800">
+                <a:solidFill>
+                  <a:srgbClr val="1F2937"/>
+                </a:solidFill>
+              </a:defRPr>
+            </a:pPr>
+            <a:r>
+              <a:rPr dirty="0"/>
+              <a:t>Hallucination guard returns a safe not-found message when no relevant chunks are found.</a:t>
+            </a:r>
+          </a:p>
+          <a:p>
+            <a:pPr>
+              <a:spcAft>
+                <a:spcPts val="800"/>
+              </a:spcAft>
+              <a:defRPr sz="1800">
+                <a:solidFill>
+                  <a:srgbClr val="1F2937"/>
+                </a:solidFill>
+              </a:defRPr>
+            </a:pPr>
+            <a:r>
+              <a:rPr dirty="0" err="1"/>
+              <a:t>Streamlit</a:t>
+            </a:r>
+            <a:r>
+              <a:rPr dirty="0"/>
+              <a:t> UI shows chat history, sources, Knowledge Scope filter, and Clear/Reset.</a:t>
+            </a:r>
+          </a:p>
+        </p:txBody>
+      </p:sp>
     </p:spTree>
   </p:cSld>
   <p:clrMapOvr>
@@ -4104,7 +6146,7 @@
               </a:defRPr>
             </a:pPr>
             <a:r>
-              <a:t>Demo Flow</a:t>
+              <a:t>Technology Stack</a:t>
             </a:r>
           </a:p>
         </p:txBody>
@@ -4118,7 +6160,7 @@
         <p:spPr>
           <a:xfrm>
             <a:off x="640080" y="1097280"/>
-            <a:ext cx="4904548" cy="1508105"/>
+            <a:ext cx="8046720" cy="5303520"/>
           </a:xfrm>
           <a:prstGeom prst="rect">
             <a:avLst/>
@@ -4142,64 +6184,112 @@
               </a:defRPr>
             </a:pPr>
             <a:r>
-              <a:rPr dirty="0"/>
-              <a:t>1. Run setup.bat and python scripts/ingest.py</a:t>
-            </a:r>
-          </a:p>
-          <a:p>
-            <a:pPr>
-              <a:spcAft>
-                <a:spcPts val="800"/>
-              </a:spcAft>
-              <a:defRPr sz="1800">
-                <a:solidFill>
-                  <a:srgbClr val="1F2937"/>
-                </a:solidFill>
-              </a:defRPr>
-            </a:pPr>
-            <a:r>
-              <a:rPr dirty="0"/>
-              <a:t>2. Start app with start.bat → http://localhost:8501</a:t>
-            </a:r>
-          </a:p>
-          <a:p>
-            <a:pPr>
-              <a:spcAft>
-                <a:spcPts val="800"/>
-              </a:spcAft>
-              <a:defRPr sz="1800">
-                <a:solidFill>
-                  <a:srgbClr val="1F2937"/>
-                </a:solidFill>
-              </a:defRPr>
-            </a:pPr>
-            <a:r>
-              <a:rPr dirty="0"/>
-              <a:t>3. Ask: What is the leave policy?</a:t>
-            </a:r>
-          </a:p>
-          <a:p>
-            <a:pPr>
-              <a:spcAft>
-                <a:spcPts val="800"/>
-              </a:spcAft>
-              <a:defRPr sz="1800">
-                <a:solidFill>
-                  <a:srgbClr val="1F2937"/>
-                </a:solidFill>
-              </a:defRPr>
-            </a:pPr>
-            <a:r>
-              <a:rPr lang="en-US" dirty="0" smtClean="0"/>
-              <a:t>4</a:t>
-            </a:r>
-            <a:r>
-              <a:rPr dirty="0" smtClean="0"/>
-              <a:t>. </a:t>
-            </a:r>
-            <a:r>
-              <a:rPr dirty="0"/>
-              <a:t>Show source citations and Clear/Reset button</a:t>
+              <a:t>Language: Python 3.10+</a:t>
+            </a:r>
+          </a:p>
+          <a:p>
+            <a:pPr>
+              <a:spcAft>
+                <a:spcPts val="800"/>
+              </a:spcAft>
+              <a:defRPr sz="1800">
+                <a:solidFill>
+                  <a:srgbClr val="1F2937"/>
+                </a:solidFill>
+              </a:defRPr>
+            </a:pPr>
+            <a:r>
+              <a:t>UI: Streamlit</a:t>
+            </a:r>
+          </a:p>
+          <a:p>
+            <a:pPr>
+              <a:spcAft>
+                <a:spcPts val="800"/>
+              </a:spcAft>
+              <a:defRPr sz="1800">
+                <a:solidFill>
+                  <a:srgbClr val="1F2937"/>
+                </a:solidFill>
+              </a:defRPr>
+            </a:pPr>
+            <a:r>
+              <a:t>Framework: LangChain</a:t>
+            </a:r>
+          </a:p>
+          <a:p>
+            <a:pPr>
+              <a:spcAft>
+                <a:spcPts val="800"/>
+              </a:spcAft>
+              <a:defRPr sz="1800">
+                <a:solidFill>
+                  <a:srgbClr val="1F2937"/>
+                </a:solidFill>
+              </a:defRPr>
+            </a:pPr>
+            <a:r>
+              <a:t>LLM &amp; Embeddings: OpenAI (gpt-4o-mini, text-embedding-3-small)</a:t>
+            </a:r>
+          </a:p>
+          <a:p>
+            <a:pPr>
+              <a:spcAft>
+                <a:spcPts val="800"/>
+              </a:spcAft>
+              <a:defRPr sz="1800">
+                <a:solidFill>
+                  <a:srgbClr val="1F2937"/>
+                </a:solidFill>
+              </a:defRPr>
+            </a:pPr>
+            <a:r>
+              <a:t>Vector Database: ChromaDB</a:t>
+            </a:r>
+          </a:p>
+          <a:p>
+            <a:pPr>
+              <a:spcAft>
+                <a:spcPts val="800"/>
+              </a:spcAft>
+              <a:defRPr sz="1800">
+                <a:solidFill>
+                  <a:srgbClr val="1F2937"/>
+                </a:solidFill>
+              </a:defRPr>
+            </a:pPr>
+            <a:r>
+              <a:t>Keyword Search: BM25 (rank-bm25)</a:t>
+            </a:r>
+          </a:p>
+          <a:p>
+            <a:pPr>
+              <a:spcAft>
+                <a:spcPts val="800"/>
+              </a:spcAft>
+              <a:defRPr sz="1800">
+                <a:solidFill>
+                  <a:srgbClr val="1F2937"/>
+                </a:solidFill>
+              </a:defRPr>
+            </a:pPr>
+            <a:r>
+              <a:t>Reranking: sentence-transformers cross-encoder</a:t>
+            </a:r>
+          </a:p>
+          <a:p>
+            <a:pPr>
+              <a:spcAft>
+                <a:spcPts val="800"/>
+              </a:spcAft>
+              <a:defRPr sz="1800">
+                <a:solidFill>
+                  <a:srgbClr val="1F2937"/>
+                </a:solidFill>
+              </a:defRPr>
+            </a:pPr>
+            <a:r>
+              <a:t>Config: pydantic-settings + .env</a:t>
             </a:r>
           </a:p>
         </p:txBody>
@@ -4259,7 +6349,7 @@
               </a:defRPr>
             </a:pPr>
             <a:r>
-              <a:t>How to Run</a:t>
+              <a:t>Key Features Implemented</a:t>
             </a:r>
           </a:p>
         </p:txBody>
@@ -4297,82 +6387,112 @@
               </a:defRPr>
             </a:pPr>
             <a:r>
-              <a:t>1. setup.bat (first time only)</a:t>
-            </a:r>
-          </a:p>
-          <a:p>
-            <a:pPr>
-              <a:spcAft>
-                <a:spcPts val="800"/>
-              </a:spcAft>
-              <a:defRPr sz="1800">
-                <a:solidFill>
-                  <a:srgbClr val="1F2937"/>
-                </a:solidFill>
-              </a:defRPr>
-            </a:pPr>
-            <a:r>
-              <a:t>2. copy .env.example .env and add OPENAI_API_KEY</a:t>
-            </a:r>
-          </a:p>
-          <a:p>
-            <a:pPr>
-              <a:spcAft>
-                <a:spcPts val="800"/>
-              </a:spcAft>
-              <a:defRPr sz="1800">
-                <a:solidFill>
-                  <a:srgbClr val="1F2937"/>
-                </a:solidFill>
-              </a:defRPr>
-            </a:pPr>
-            <a:r>
-              <a:t>3. python scripts/ingest.py</a:t>
-            </a:r>
-          </a:p>
-          <a:p>
-            <a:pPr>
-              <a:spcAft>
-                <a:spcPts val="800"/>
-              </a:spcAft>
-              <a:defRPr sz="1800">
-                <a:solidFill>
-                  <a:srgbClr val="1F2937"/>
-                </a:solidFill>
-              </a:defRPr>
-            </a:pPr>
-            <a:r>
-              <a:t>4. start.bat</a:t>
-            </a:r>
-          </a:p>
-          <a:p>
-            <a:pPr>
-              <a:spcAft>
-                <a:spcPts val="800"/>
-              </a:spcAft>
-              <a:defRPr sz="1800">
-                <a:solidFill>
-                  <a:srgbClr val="1F2937"/>
-                </a:solidFill>
-              </a:defRPr>
-            </a:pPr>
-            <a:r>
-              <a:t>5. Open http://localhost:8501</a:t>
-            </a:r>
-          </a:p>
-          <a:p>
-            <a:pPr>
-              <a:spcAft>
-                <a:spcPts val="800"/>
-              </a:spcAft>
-              <a:defRPr sz="1800">
-                <a:solidFill>
-                  <a:srgbClr val="1F2937"/>
-                </a:solidFill>
-              </a:defRPr>
-            </a:pPr>
-            <a:r>
-              <a:t>Submission docs available in SubmissionDocument/ folder.</a:t>
+              <a:t>Document ingestion from local folder (PDF, DOCX, TXT)</a:t>
+            </a:r>
+          </a:p>
+          <a:p>
+            <a:pPr>
+              <a:spcAft>
+                <a:spcPts val="800"/>
+              </a:spcAft>
+              <a:defRPr sz="1800">
+                <a:solidFill>
+                  <a:srgbClr val="1F2937"/>
+                </a:solidFill>
+              </a:defRPr>
+            </a:pPr>
+            <a:r>
+              <a:t>Chunking, embeddings, and vector storage</a:t>
+            </a:r>
+          </a:p>
+          <a:p>
+            <a:pPr>
+              <a:spcAft>
+                <a:spcPts val="800"/>
+              </a:spcAft>
+              <a:defRPr sz="1800">
+                <a:solidFill>
+                  <a:srgbClr val="1F2937"/>
+                </a:solidFill>
+              </a:defRPr>
+            </a:pPr>
+            <a:r>
+              <a:t>Semantic retrieval + BM25 hybrid search</a:t>
+            </a:r>
+          </a:p>
+          <a:p>
+            <a:pPr>
+              <a:spcAft>
+                <a:spcPts val="800"/>
+              </a:spcAft>
+              <a:defRPr sz="1800">
+                <a:solidFill>
+                  <a:srgbClr val="1F2937"/>
+                </a:solidFill>
+              </a:defRPr>
+            </a:pPr>
+            <a:r>
+              <a:t>Cross-encoder reranking for relevance</a:t>
+            </a:r>
+          </a:p>
+          <a:p>
+            <a:pPr>
+              <a:spcAft>
+                <a:spcPts val="800"/>
+              </a:spcAft>
+              <a:defRPr sz="1800">
+                <a:solidFill>
+                  <a:srgbClr val="1F2937"/>
+                </a:solidFill>
+              </a:defRPr>
+            </a:pPr>
+            <a:r>
+              <a:t>Conversational memory for follow-up questions</a:t>
+            </a:r>
+          </a:p>
+          <a:p>
+            <a:pPr>
+              <a:spcAft>
+                <a:spcPts val="800"/>
+              </a:spcAft>
+              <a:defRPr sz="1800">
+                <a:solidFill>
+                  <a:srgbClr val="1F2937"/>
+                </a:solidFill>
+              </a:defRPr>
+            </a:pPr>
+            <a:r>
+              <a:t>Source citations displayed in the UI</a:t>
+            </a:r>
+          </a:p>
+          <a:p>
+            <a:pPr>
+              <a:spcAft>
+                <a:spcPts val="800"/>
+              </a:spcAft>
+              <a:defRPr sz="1800">
+                <a:solidFill>
+                  <a:srgbClr val="1F2937"/>
+                </a:solidFill>
+              </a:defRPr>
+            </a:pPr>
+            <a:r>
+              <a:t>Hallucination guard with clear not-found responses</a:t>
+            </a:r>
+          </a:p>
+          <a:p>
+            <a:pPr>
+              <a:spcAft>
+                <a:spcPts val="800"/>
+              </a:spcAft>
+              <a:defRPr sz="1800">
+                <a:solidFill>
+                  <a:srgbClr val="1F2937"/>
+                </a:solidFill>
+              </a:defRPr>
+            </a:pPr>
+            <a:r>
+              <a:t>Startup preload of search models</a:t>
             </a:r>
           </a:p>
         </p:txBody>
@@ -4388,14 +6508,6 @@
 <file path=ppt/slides/slide9.xml><?xml version="1.0" encoding="utf-8"?>
 <p:sld xmlns:a="http://schemas.openxmlformats.org/drawingml/2006/main" xmlns:r="http://schemas.openxmlformats.org/officeDocument/2006/relationships" xmlns:p="http://schemas.openxmlformats.org/presentationml/2006/main">
   <p:cSld>
-    <p:bg>
-      <p:bgPr>
-        <a:solidFill>
-          <a:srgbClr val="1565C0"/>
-        </a:solidFill>
-        <a:effectLst/>
-      </p:bgPr>
-    </p:bg>
     <p:spTree>
       <p:nvGrpSpPr>
         <p:cNvPr id="1" name=""/>
@@ -4418,8 +6530,8 @@
         </p:nvSpPr>
         <p:spPr>
           <a:xfrm>
-            <a:off x="640080" y="1828800"/>
-            <a:ext cx="7863840" cy="1371600"/>
+            <a:off x="457200" y="320040"/>
+            <a:ext cx="8229600" cy="731520"/>
           </a:xfrm>
           <a:prstGeom prst="rect">
             <a:avLst/>
@@ -4432,15 +6544,15 @@
           </a:bodyPr>
           <a:lstStyle/>
           <a:p>
-            <a:pPr algn="ctr">
-              <a:defRPr sz="3600" b="1">
-                <a:solidFill>
-                  <a:srgbClr val="FFFFFF"/>
-                </a:solidFill>
-              </a:defRPr>
-            </a:pPr>
-            <a:r>
-              <a:t>Thank You</a:t>
+            <a:pPr>
+              <a:defRPr sz="3000" b="1">
+                <a:solidFill>
+                  <a:srgbClr val="1565C0"/>
+                </a:solidFill>
+              </a:defRPr>
+            </a:pPr>
+            <a:r>
+              <a:t>Sample Documents</a:t>
             </a:r>
           </a:p>
         </p:txBody>
@@ -4453,8 +6565,8 @@
         </p:nvSpPr>
         <p:spPr>
           <a:xfrm>
-            <a:off x="2567297" y="3291840"/>
-            <a:ext cx="3123676" cy="646331"/>
+            <a:off x="640080" y="1097280"/>
+            <a:ext cx="8046720" cy="5303520"/>
           </a:xfrm>
           <a:prstGeom prst="rect">
             <a:avLst/>
@@ -4467,29 +6579,124 @@
           </a:bodyPr>
           <a:lstStyle/>
           <a:p>
-            <a:r>
-              <a:rPr smtClean="0"/>
-              <a:t>Vivek</a:t>
-            </a:r>
-            <a:r>
-              <a:rPr dirty="0" smtClean="0"/>
-              <a:t> </a:t>
-            </a:r>
-            <a:r>
-              <a:rPr dirty="0"/>
-              <a:t>Kumar</a:t>
-            </a:r>
-          </a:p>
-          <a:p>
-            <a:r>
-              <a:rPr dirty="0"/>
-              <a:t>Enterprise Knowledge </a:t>
-            </a:r>
-            <a:r>
-              <a:rPr dirty="0" smtClean="0"/>
-              <a:t>Assistant</a:t>
-            </a:r>
-            <a:endParaRPr dirty="0"/>
+            <a:pPr>
+              <a:spcAft>
+                <a:spcPts val="800"/>
+              </a:spcAft>
+              <a:defRPr sz="1800">
+                <a:solidFill>
+                  <a:srgbClr val="1F2937"/>
+                </a:solidFill>
+              </a:defRPr>
+            </a:pPr>
+            <a:r>
+              <a:t>Leave_Policy.pdf</a:t>
+            </a:r>
+          </a:p>
+          <a:p>
+            <a:pPr>
+              <a:spcAft>
+                <a:spcPts val="800"/>
+              </a:spcAft>
+              <a:defRPr sz="1800">
+                <a:solidFill>
+                  <a:srgbClr val="1F2937"/>
+                </a:solidFill>
+              </a:defRPr>
+            </a:pPr>
+            <a:r>
+              <a:t>HR_Handbook.pdf</a:t>
+            </a:r>
+          </a:p>
+          <a:p>
+            <a:pPr>
+              <a:spcAft>
+                <a:spcPts val="800"/>
+              </a:spcAft>
+              <a:defRPr sz="1800">
+                <a:solidFill>
+                  <a:srgbClr val="1F2937"/>
+                </a:solidFill>
+              </a:defRPr>
+            </a:pPr>
+            <a:r>
+              <a:t>IT_Policy.txt</a:t>
+            </a:r>
+          </a:p>
+          <a:p>
+            <a:pPr>
+              <a:spcAft>
+                <a:spcPts val="800"/>
+              </a:spcAft>
+              <a:defRPr sz="1800">
+                <a:solidFill>
+                  <a:srgbClr val="1F2937"/>
+                </a:solidFill>
+              </a:defRPr>
+            </a:pPr>
+            <a:r>
+              <a:t>Travel_Policy.txt</a:t>
+            </a:r>
+          </a:p>
+          <a:p>
+            <a:pPr>
+              <a:spcAft>
+                <a:spcPts val="800"/>
+              </a:spcAft>
+              <a:defRPr sz="1800">
+                <a:solidFill>
+                  <a:srgbClr val="1F2937"/>
+                </a:solidFill>
+              </a:defRPr>
+            </a:pPr>
+            <a:r>
+              <a:t>Benefits_Documentation.txt</a:t>
+            </a:r>
+          </a:p>
+          <a:p>
+            <a:pPr>
+              <a:spcAft>
+                <a:spcPts val="800"/>
+              </a:spcAft>
+              <a:defRPr sz="1800">
+                <a:solidFill>
+                  <a:srgbClr val="1F2937"/>
+                </a:solidFill>
+              </a:defRPr>
+            </a:pPr>
+            <a:r>
+              <a:t>Code_of_Conduct.txt</a:t>
+            </a:r>
+          </a:p>
+          <a:p>
+            <a:pPr>
+              <a:spcAft>
+                <a:spcPts val="800"/>
+              </a:spcAft>
+              <a:defRPr sz="1800">
+                <a:solidFill>
+                  <a:srgbClr val="1F2937"/>
+                </a:solidFill>
+              </a:defRPr>
+            </a:pPr>
+            <a:r>
+              <a:t>Company_FAQs.txt</a:t>
+            </a:r>
+          </a:p>
+          <a:p>
+            <a:pPr>
+              <a:spcAft>
+                <a:spcPts val="800"/>
+              </a:spcAft>
+              <a:defRPr sz="1800">
+                <a:solidFill>
+                  <a:srgbClr val="1F2937"/>
+                </a:solidFill>
+              </a:defRPr>
+            </a:pPr>
+            <a:r>
+              <a:t>Evaluator can run the app without creating data from scratch.</a:t>
+            </a:r>
           </a:p>
         </p:txBody>
       </p:sp>

</xml_diff>

<commit_message>
Update Enterprise Knowledge Assistant app, docs, and helper scripts.
Add welcome UI with source citations, startup/reindex utilities, and refreshed submission docs without including local secrets or OtherActivity assets.

Co-authored-by: Cursor <cursoragent@cursor.com>
</commit_message>
<xml_diff>
--- a/SubmissionDocument/Enterprise_Knowledge_Assistant_Vivek_kumar.pptx
+++ b/SubmissionDocument/Enterprise_Knowledge_Assistant_Vivek_kumar.pptx
@@ -5,22 +5,23 @@
     <p:sldMasterId id="2147483648" r:id="rId1"/>
   </p:sldMasterIdLst>
   <p:sldIdLst>
-    <p:sldId id="256" r:id="rId2"/>
-    <p:sldId id="257" r:id="rId3"/>
-    <p:sldId id="258" r:id="rId4"/>
-    <p:sldId id="259" r:id="rId5"/>
-    <p:sldId id="260" r:id="rId6"/>
-    <p:sldId id="261" r:id="rId7"/>
-    <p:sldId id="262" r:id="rId8"/>
-    <p:sldId id="263" r:id="rId9"/>
-    <p:sldId id="264" r:id="rId10"/>
-    <p:sldId id="265" r:id="rId11"/>
-    <p:sldId id="266" r:id="rId12"/>
-    <p:sldId id="267" r:id="rId13"/>
-    <p:sldId id="268" r:id="rId14"/>
-    <p:sldId id="269" r:id="rId15"/>
-    <p:sldId id="271" r:id="rId16"/>
-    <p:sldId id="272" r:id="rId17"/>
+    <p:sldId id="256" r:id="rId7"/>
+    <p:sldId id="257" r:id="rId8"/>
+    <p:sldId id="258" r:id="rId9"/>
+    <p:sldId id="259" r:id="rId10"/>
+    <p:sldId id="260" r:id="rId11"/>
+    <p:sldId id="261" r:id="rId12"/>
+    <p:sldId id="262" r:id="rId13"/>
+    <p:sldId id="263" r:id="rId14"/>
+    <p:sldId id="264" r:id="rId15"/>
+    <p:sldId id="265" r:id="rId16"/>
+    <p:sldId id="266" r:id="rId17"/>
+    <p:sldId id="267" r:id="rId18"/>
+    <p:sldId id="268" r:id="rId19"/>
+    <p:sldId id="269" r:id="rId20"/>
+    <p:sldId id="270" r:id="rId21"/>
+    <p:sldId id="271" r:id="rId22"/>
+    <p:sldId id="272" r:id="rId23"/>
   </p:sldIdLst>
   <p:sldSz cx="9144000" cy="6858000" type="screen4x3"/>
   <p:notesSz cx="6858000" cy="9144000"/>
@@ -119,22 +120,6 @@
       </a:defRPr>
     </a:lvl9pPr>
   </p:defaultTextStyle>
-  <p:extLst>
-    <p:ext uri="{EFAFB233-063F-42B5-8137-9DF3F51BA10A}">
-      <p15:sldGuideLst xmlns:p15="http://schemas.microsoft.com/office/powerpoint/2012/main">
-        <p15:guide id="1" orient="horz" pos="2160">
-          <p15:clr>
-            <a:srgbClr val="A4A3A4"/>
-          </p15:clr>
-        </p15:guide>
-        <p15:guide id="2" pos="2880">
-          <p15:clr>
-            <a:srgbClr val="A4A3A4"/>
-          </p15:clr>
-        </p15:guide>
-      </p15:sldGuideLst>
-    </p:ext>
-  </p:extLst>
 </p:presentation>
 </file>
 
@@ -319,7 +304,7 @@
           <a:p>
             <a:fld id="{5BCAD085-E8A6-8845-BD4E-CB4CCA059FC4}" type="datetimeFigureOut">
               <a:rPr lang="en-US" smtClean="0"/>
-              <a:t>9/13/2026</a:t>
+              <a:t>1/27/13</a:t>
             </a:fld>
             <a:endParaRPr lang="en-US"/>
           </a:p>
@@ -489,7 +474,7 @@
           <a:p>
             <a:fld id="{5BCAD085-E8A6-8845-BD4E-CB4CCA059FC4}" type="datetimeFigureOut">
               <a:rPr lang="en-US" smtClean="0"/>
-              <a:t>9/13/2026</a:t>
+              <a:t>1/27/13</a:t>
             </a:fld>
             <a:endParaRPr lang="en-US"/>
           </a:p>
@@ -669,7 +654,7 @@
           <a:p>
             <a:fld id="{5BCAD085-E8A6-8845-BD4E-CB4CCA059FC4}" type="datetimeFigureOut">
               <a:rPr lang="en-US" smtClean="0"/>
-              <a:t>9/13/2026</a:t>
+              <a:t>1/27/13</a:t>
             </a:fld>
             <a:endParaRPr lang="en-US"/>
           </a:p>
@@ -839,7 +824,7 @@
           <a:p>
             <a:fld id="{5BCAD085-E8A6-8845-BD4E-CB4CCA059FC4}" type="datetimeFigureOut">
               <a:rPr lang="en-US" smtClean="0"/>
-              <a:t>9/13/2026</a:t>
+              <a:t>1/27/13</a:t>
             </a:fld>
             <a:endParaRPr lang="en-US"/>
           </a:p>
@@ -1085,7 +1070,7 @@
           <a:p>
             <a:fld id="{5BCAD085-E8A6-8845-BD4E-CB4CCA059FC4}" type="datetimeFigureOut">
               <a:rPr lang="en-US" smtClean="0"/>
-              <a:t>9/13/2026</a:t>
+              <a:t>1/27/13</a:t>
             </a:fld>
             <a:endParaRPr lang="en-US"/>
           </a:p>
@@ -1373,7 +1358,7 @@
           <a:p>
             <a:fld id="{5BCAD085-E8A6-8845-BD4E-CB4CCA059FC4}" type="datetimeFigureOut">
               <a:rPr lang="en-US" smtClean="0"/>
-              <a:t>9/13/2026</a:t>
+              <a:t>1/27/13</a:t>
             </a:fld>
             <a:endParaRPr lang="en-US"/>
           </a:p>
@@ -1795,7 +1780,7 @@
           <a:p>
             <a:fld id="{5BCAD085-E8A6-8845-BD4E-CB4CCA059FC4}" type="datetimeFigureOut">
               <a:rPr lang="en-US" smtClean="0"/>
-              <a:t>9/13/2026</a:t>
+              <a:t>1/27/13</a:t>
             </a:fld>
             <a:endParaRPr lang="en-US"/>
           </a:p>
@@ -1913,7 +1898,7 @@
           <a:p>
             <a:fld id="{5BCAD085-E8A6-8845-BD4E-CB4CCA059FC4}" type="datetimeFigureOut">
               <a:rPr lang="en-US" smtClean="0"/>
-              <a:t>9/13/2026</a:t>
+              <a:t>1/27/13</a:t>
             </a:fld>
             <a:endParaRPr lang="en-US"/>
           </a:p>
@@ -2008,7 +1993,7 @@
           <a:p>
             <a:fld id="{5BCAD085-E8A6-8845-BD4E-CB4CCA059FC4}" type="datetimeFigureOut">
               <a:rPr lang="en-US" smtClean="0"/>
-              <a:t>9/13/2026</a:t>
+              <a:t>1/27/13</a:t>
             </a:fld>
             <a:endParaRPr lang="en-US"/>
           </a:p>
@@ -2285,7 +2270,7 @@
           <a:p>
             <a:fld id="{5BCAD085-E8A6-8845-BD4E-CB4CCA059FC4}" type="datetimeFigureOut">
               <a:rPr lang="en-US" smtClean="0"/>
-              <a:t>9/13/2026</a:t>
+              <a:t>1/27/13</a:t>
             </a:fld>
             <a:endParaRPr lang="en-US"/>
           </a:p>
@@ -2538,7 +2523,7 @@
           <a:p>
             <a:fld id="{5BCAD085-E8A6-8845-BD4E-CB4CCA059FC4}" type="datetimeFigureOut">
               <a:rPr lang="en-US" smtClean="0"/>
-              <a:t>9/13/2026</a:t>
+              <a:t>1/27/13</a:t>
             </a:fld>
             <a:endParaRPr lang="en-US"/>
           </a:p>
@@ -2751,7 +2736,7 @@
           <a:p>
             <a:fld id="{5BCAD085-E8A6-8845-BD4E-CB4CCA059FC4}" type="datetimeFigureOut">
               <a:rPr lang="en-US" smtClean="0"/>
-              <a:t>9/13/2026</a:t>
+              <a:t>1/27/13</a:t>
             </a:fld>
             <a:endParaRPr lang="en-US"/>
           </a:p>
@@ -3110,7 +3095,7 @@
 </file>
 
 <file path=ppt/slides/slide1.xml><?xml version="1.0" encoding="utf-8"?>
-<p:sld xmlns:a="http://schemas.openxmlformats.org/drawingml/2006/main" xmlns:r="http://schemas.openxmlformats.org/officeDocument/2006/relationships" xmlns:p="http://schemas.openxmlformats.org/presentationml/2006/main">
+<p:sld xmlns:a="http://schemas.openxmlformats.org/drawingml/2006/main" xmlns:p="http://schemas.openxmlformats.org/presentationml/2006/main" xmlns:r="http://schemas.openxmlformats.org/officeDocument/2006/relationships">
   <p:cSld>
     <p:bg>
       <p:bgPr>
@@ -3126,14 +3111,7 @@
         <p:cNvGrpSpPr/>
         <p:nvPr/>
       </p:nvGrpSpPr>
-      <p:grpSpPr>
-        <a:xfrm>
-          <a:off x="0" y="0"/>
-          <a:ext cx="0" cy="0"/>
-          <a:chOff x="0" y="0"/>
-          <a:chExt cx="0" cy="0"/>
-        </a:xfrm>
-      </p:grpSpPr>
+      <p:grpSpPr/>
       <p:sp>
         <p:nvSpPr>
           <p:cNvPr id="2" name="TextBox 1"/>
@@ -3177,8 +3155,8 @@
         </p:nvSpPr>
         <p:spPr>
           <a:xfrm>
-            <a:off x="1530109" y="3291840"/>
-            <a:ext cx="6083781" cy="954107"/>
+            <a:off x="640080" y="3291840"/>
+            <a:ext cx="7863840" cy="1097280"/>
           </a:xfrm>
           <a:prstGeom prst="rect">
             <a:avLst/>
@@ -3199,40 +3177,17 @@
               </a:defRPr>
             </a:pPr>
             <a:r>
-              <a:rPr dirty="0"/>
               <a:t>Project 2 — Advanced RAG Application</a:t>
             </a:r>
           </a:p>
           <a:p>
             <a:r>
-              <a:rPr dirty="0" err="1"/>
-              <a:t>Vivek</a:t>
-            </a:r>
-            <a:r>
-              <a:rPr dirty="0"/>
-              <a:t> Kumar | IIT Patna </a:t>
-            </a:r>
-            <a:r>
-              <a:rPr dirty="0" err="1" smtClean="0"/>
-              <a:t>GenAI</a:t>
-            </a:r>
-            <a:r>
-              <a:rPr dirty="0" smtClean="0"/>
-              <a:t> </a:t>
-            </a:r>
-            <a:r>
-              <a:rPr dirty="0"/>
-              <a:t>Development Program</a:t>
-            </a:r>
-          </a:p>
-          <a:p>
-            <a:r>
-              <a:rPr dirty="0" err="1"/>
-              <a:t>Oeeggis</a:t>
-            </a:r>
-            <a:r>
-              <a:rPr dirty="0"/>
-              <a:t> Corporation (Fictional — Academic Project)</a:t>
+              <a:t>Vivek Kumar | IIT Patna GenAI Development Program</a:t>
+            </a:r>
+          </a:p>
+          <a:p>
+            <a:r>
+              <a:t>Oeeggis Corporation (Fictional — Academic Project)</a:t>
             </a:r>
           </a:p>
         </p:txBody>
@@ -3246,7 +3201,7 @@
 </file>
 
 <file path=ppt/slides/slide10.xml><?xml version="1.0" encoding="utf-8"?>
-<p:sld xmlns:a="http://schemas.openxmlformats.org/drawingml/2006/main" xmlns:r="http://schemas.openxmlformats.org/officeDocument/2006/relationships" xmlns:p="http://schemas.openxmlformats.org/presentationml/2006/main">
+<p:sld xmlns:a="http://schemas.openxmlformats.org/drawingml/2006/main" xmlns:p="http://schemas.openxmlformats.org/presentationml/2006/main" xmlns:r="http://schemas.openxmlformats.org/officeDocument/2006/relationships">
   <p:cSld>
     <p:spTree>
       <p:nvGrpSpPr>
@@ -3254,14 +3209,7 @@
         <p:cNvGrpSpPr/>
         <p:nvPr/>
       </p:nvGrpSpPr>
-      <p:grpSpPr>
-        <a:xfrm>
-          <a:off x="0" y="0"/>
-          <a:ext cx="0" cy="0"/>
-          <a:chOff x="0" y="0"/>
-          <a:chExt cx="0" cy="0"/>
-        </a:xfrm>
-      </p:grpSpPr>
+      <p:grpSpPr/>
       <p:sp>
         <p:nvSpPr>
           <p:cNvPr id="2" name="TextBox 1"/>
@@ -3329,8 +3277,8 @@
         </p:nvSpPr>
         <p:spPr>
           <a:xfrm>
-            <a:off x="261256" y="3770500"/>
-            <a:ext cx="8425543" cy="1123384"/>
+            <a:off x="5943600" y="868680"/>
+            <a:ext cx="2926080" cy="5669280"/>
           </a:xfrm>
           <a:prstGeom prst="rect">
             <a:avLst/>
@@ -3338,7 +3286,7 @@
           <a:noFill/>
         </p:spPr>
         <p:txBody>
-          <a:bodyPr wrap="square">
+          <a:bodyPr wrap="none">
             <a:spAutoFit/>
           </a:bodyPr>
           <a:lstStyle/>
@@ -3354,32 +3302,7 @@
               </a:defRPr>
             </a:pPr>
             <a:r>
-              <a:rPr dirty="0"/>
-              <a:t>Header: </a:t>
-            </a:r>
-            <a:r>
-              <a:rPr dirty="0" err="1"/>
-              <a:t>Oeeggis</a:t>
-            </a:r>
-            <a:r>
-              <a:rPr dirty="0"/>
-              <a:t> Corporation branding and app </a:t>
-            </a:r>
-            <a:r>
-              <a:rPr dirty="0" smtClean="0"/>
-              <a:t>title.</a:t>
-            </a:r>
-            <a:r>
-              <a:rPr lang="en-US" dirty="0" smtClean="0"/>
-              <a:t> </a:t>
-            </a:r>
-            <a:r>
-              <a:rPr dirty="0" smtClean="0"/>
-              <a:t>Sidebar </a:t>
-            </a:r>
-            <a:r>
-              <a:rPr dirty="0"/>
-              <a:t>— Knowledge Scope lists all indexed policy documents.</a:t>
+              <a:t>Header: Oeeggis Corporation branding and app title.</a:t>
             </a:r>
           </a:p>
           <a:p>
@@ -3394,24 +3317,7 @@
               </a:defRPr>
             </a:pPr>
             <a:r>
-              <a:rPr dirty="0"/>
-              <a:t>User can see which topics the assistant can answer from</a:t>
-            </a:r>
-            <a:r>
-              <a:rPr dirty="0" smtClean="0"/>
-              <a:t>.</a:t>
-            </a:r>
-            <a:r>
-              <a:rPr lang="en-US" dirty="0" smtClean="0"/>
-              <a:t> </a:t>
-            </a:r>
-            <a:r>
-              <a:rPr dirty="0" smtClean="0"/>
-              <a:t>Main </a:t>
-            </a:r>
-            <a:r>
-              <a:rPr dirty="0"/>
-              <a:t>chat area shows welcome message from the assistant.</a:t>
+              <a:t>Sidebar — Knowledge Scope lists all indexed policy documents.</a:t>
             </a:r>
           </a:p>
           <a:p>
@@ -3426,20 +3332,7 @@
               </a:defRPr>
             </a:pPr>
             <a:r>
-              <a:rPr dirty="0"/>
-              <a:t>Chat input at bottom: type policy questions in natural </a:t>
-            </a:r>
-            <a:r>
-              <a:rPr dirty="0" err="1" smtClean="0"/>
-              <a:t>language.Clear</a:t>
-            </a:r>
-            <a:r>
-              <a:rPr dirty="0" smtClean="0"/>
-              <a:t> </a:t>
-            </a:r>
-            <a:r>
-              <a:rPr dirty="0"/>
-              <a:t>/ Reset button clears chat history and memory.</a:t>
+              <a:t>User can see which topics the assistant can answer from.</a:t>
             </a:r>
           </a:p>
           <a:p>
@@ -3454,18 +3347,68 @@
               </a:defRPr>
             </a:pPr>
             <a:r>
-              <a:rPr dirty="0"/>
-              <a:t>Footer disclaimer: academic/fictional company notice</a:t>
-            </a:r>
-            <a:r>
-              <a:rPr dirty="0" smtClean="0"/>
-              <a:t>.</a:t>
-            </a:r>
-            <a:r>
-              <a:rPr lang="en-US" dirty="0" smtClean="0"/>
-              <a:t> </a:t>
-            </a:r>
-            <a:endParaRPr dirty="0"/>
+              <a:t>Main chat area shows welcome message from the assistant.</a:t>
+            </a:r>
+          </a:p>
+          <a:p>
+            <a:pPr>
+              <a:spcAft>
+                <a:spcPts val="600"/>
+              </a:spcAft>
+              <a:defRPr sz="1300">
+                <a:solidFill>
+                  <a:srgbClr val="1F2937"/>
+                </a:solidFill>
+              </a:defRPr>
+            </a:pPr>
+            <a:r>
+              <a:t>Chat input at bottom: type policy questions in natural language.</a:t>
+            </a:r>
+          </a:p>
+          <a:p>
+            <a:pPr>
+              <a:spcAft>
+                <a:spcPts val="600"/>
+              </a:spcAft>
+              <a:defRPr sz="1300">
+                <a:solidFill>
+                  <a:srgbClr val="1F2937"/>
+                </a:solidFill>
+              </a:defRPr>
+            </a:pPr>
+            <a:r>
+              <a:t>Clear / Reset button clears chat history and memory.</a:t>
+            </a:r>
+          </a:p>
+          <a:p>
+            <a:pPr>
+              <a:spcAft>
+                <a:spcPts val="600"/>
+              </a:spcAft>
+              <a:defRPr sz="1300">
+                <a:solidFill>
+                  <a:srgbClr val="1F2937"/>
+                </a:solidFill>
+              </a:defRPr>
+            </a:pPr>
+            <a:r>
+              <a:t>Footer disclaimer: academic/fictional company notice.</a:t>
+            </a:r>
+          </a:p>
+          <a:p>
+            <a:pPr>
+              <a:spcAft>
+                <a:spcPts val="600"/>
+              </a:spcAft>
+              <a:defRPr sz="1300">
+                <a:solidFill>
+                  <a:srgbClr val="1F2937"/>
+                </a:solidFill>
+              </a:defRPr>
+            </a:pPr>
+            <a:r>
+              <a:t>On startup, search models preload in the background.</a:t>
+            </a:r>
           </a:p>
         </p:txBody>
       </p:sp>
@@ -3478,7 +3421,7 @@
 </file>
 
 <file path=ppt/slides/slide11.xml><?xml version="1.0" encoding="utf-8"?>
-<p:sld xmlns:a="http://schemas.openxmlformats.org/drawingml/2006/main" xmlns:r="http://schemas.openxmlformats.org/officeDocument/2006/relationships" xmlns:p="http://schemas.openxmlformats.org/presentationml/2006/main">
+<p:sld xmlns:a="http://schemas.openxmlformats.org/drawingml/2006/main" xmlns:p="http://schemas.openxmlformats.org/presentationml/2006/main" xmlns:r="http://schemas.openxmlformats.org/officeDocument/2006/relationships">
   <p:cSld>
     <p:spTree>
       <p:nvGrpSpPr>
@@ -3486,14 +3429,7 @@
         <p:cNvGrpSpPr/>
         <p:nvPr/>
       </p:nvGrpSpPr>
-      <p:grpSpPr>
-        <a:xfrm>
-          <a:off x="0" y="0"/>
-          <a:ext cx="0" cy="0"/>
-          <a:chOff x="0" y="0"/>
-          <a:chExt cx="0" cy="0"/>
-        </a:xfrm>
-      </p:grpSpPr>
+      <p:grpSpPr/>
       <p:sp>
         <p:nvSpPr>
           <p:cNvPr id="2" name="TextBox 1"/>
@@ -3681,7 +3617,7 @@
 </file>
 
 <file path=ppt/slides/slide12.xml><?xml version="1.0" encoding="utf-8"?>
-<p:sld xmlns:a="http://schemas.openxmlformats.org/drawingml/2006/main" xmlns:r="http://schemas.openxmlformats.org/officeDocument/2006/relationships" xmlns:p="http://schemas.openxmlformats.org/presentationml/2006/main">
+<p:sld xmlns:a="http://schemas.openxmlformats.org/drawingml/2006/main" xmlns:p="http://schemas.openxmlformats.org/presentationml/2006/main" xmlns:r="http://schemas.openxmlformats.org/officeDocument/2006/relationships">
   <p:cSld>
     <p:spTree>
       <p:nvGrpSpPr>
@@ -3689,14 +3625,7 @@
         <p:cNvGrpSpPr/>
         <p:nvPr/>
       </p:nvGrpSpPr>
-      <p:grpSpPr>
-        <a:xfrm>
-          <a:off x="0" y="0"/>
-          <a:ext cx="0" cy="0"/>
-          <a:chOff x="0" y="0"/>
-          <a:chExt cx="0" cy="0"/>
-        </a:xfrm>
-      </p:grpSpPr>
+      <p:grpSpPr/>
       <p:sp>
         <p:nvSpPr>
           <p:cNvPr id="2" name="TextBox 1"/>
@@ -3741,7 +3670,7 @@
         <p:spPr>
           <a:xfrm>
             <a:off x="640080" y="1097280"/>
-            <a:ext cx="4904548" cy="1887696"/>
+            <a:ext cx="8046720" cy="5303520"/>
           </a:xfrm>
           <a:prstGeom prst="rect">
             <a:avLst/>
@@ -3765,7 +3694,6 @@
               </a:defRPr>
             </a:pPr>
             <a:r>
-              <a:rPr dirty="0"/>
               <a:t>1. Run setup.bat and python scripts/ingest.py</a:t>
             </a:r>
           </a:p>
@@ -3781,7 +3709,6 @@
               </a:defRPr>
             </a:pPr>
             <a:r>
-              <a:rPr dirty="0"/>
               <a:t>2. Start app with start.bat → http://localhost:8501</a:t>
             </a:r>
           </a:p>
@@ -3797,7 +3724,6 @@
               </a:defRPr>
             </a:pPr>
             <a:r>
-              <a:rPr dirty="0"/>
               <a:t>3. Ask: What is the leave policy?</a:t>
             </a:r>
           </a:p>
@@ -3813,7 +3739,6 @@
               </a:defRPr>
             </a:pPr>
             <a:r>
-              <a:rPr dirty="0"/>
               <a:t>4. Follow-up: What about carry-forward?</a:t>
             </a:r>
           </a:p>
@@ -3828,7 +3753,39 @@
                 </a:solidFill>
               </a:defRPr>
             </a:pPr>
-            <a:endParaRPr dirty="0"/>
+            <a:r>
+              <a:t>5. Ask: What is the VPN policy?</a:t>
+            </a:r>
+          </a:p>
+          <a:p>
+            <a:pPr>
+              <a:spcAft>
+                <a:spcPts val="800"/>
+              </a:spcAft>
+              <a:defRPr sz="1800">
+                <a:solidFill>
+                  <a:srgbClr val="1F2937"/>
+                </a:solidFill>
+              </a:defRPr>
+            </a:pPr>
+            <a:r>
+              <a:t>6. Test not-found: What is the salary for the CEO?</a:t>
+            </a:r>
+          </a:p>
+          <a:p>
+            <a:pPr>
+              <a:spcAft>
+                <a:spcPts val="800"/>
+              </a:spcAft>
+              <a:defRPr sz="1800">
+                <a:solidFill>
+                  <a:srgbClr val="1F2937"/>
+                </a:solidFill>
+              </a:defRPr>
+            </a:pPr>
+            <a:r>
+              <a:t>7. Show source citations and Clear/Reset button</a:t>
+            </a:r>
           </a:p>
         </p:txBody>
       </p:sp>
@@ -3841,7 +3798,7 @@
 </file>
 
 <file path=ppt/slides/slide13.xml><?xml version="1.0" encoding="utf-8"?>
-<p:sld xmlns:a="http://schemas.openxmlformats.org/drawingml/2006/main" xmlns:r="http://schemas.openxmlformats.org/officeDocument/2006/relationships" xmlns:p="http://schemas.openxmlformats.org/presentationml/2006/main">
+<p:sld xmlns:a="http://schemas.openxmlformats.org/drawingml/2006/main" xmlns:p="http://schemas.openxmlformats.org/presentationml/2006/main" xmlns:r="http://schemas.openxmlformats.org/officeDocument/2006/relationships">
   <p:cSld>
     <p:spTree>
       <p:nvGrpSpPr>
@@ -3849,14 +3806,7 @@
         <p:cNvGrpSpPr/>
         <p:nvPr/>
       </p:nvGrpSpPr>
-      <p:grpSpPr>
-        <a:xfrm>
-          <a:off x="0" y="0"/>
-          <a:ext cx="0" cy="0"/>
-          <a:chOff x="0" y="0"/>
-          <a:chExt cx="0" cy="0"/>
-        </a:xfrm>
-      </p:grpSpPr>
+      <p:grpSpPr/>
       <p:sp>
         <p:nvSpPr>
           <p:cNvPr id="2" name="TextBox 1"/>
@@ -3901,7 +3851,7 @@
         <p:spPr>
           <a:xfrm>
             <a:off x="640080" y="1097280"/>
-            <a:ext cx="6038448" cy="3406061"/>
+            <a:ext cx="8046720" cy="5303520"/>
           </a:xfrm>
           <a:prstGeom prst="rect">
             <a:avLst/>
@@ -3925,7 +3875,6 @@
               </a:defRPr>
             </a:pPr>
             <a:r>
-              <a:rPr dirty="0"/>
               <a:t>Q: What is the leave policy?</a:t>
             </a:r>
           </a:p>
@@ -3941,7 +3890,6 @@
               </a:defRPr>
             </a:pPr>
             <a:r>
-              <a:rPr dirty="0"/>
               <a:t>A: Summary from leave policy documents.</a:t>
             </a:r>
           </a:p>
@@ -3957,7 +3905,6 @@
               </a:defRPr>
             </a:pPr>
             <a:r>
-              <a:rPr dirty="0"/>
               <a:t>Sources: Leave_Policy.pdf</a:t>
             </a:r>
           </a:p>
@@ -3972,21 +3919,19 @@
                 </a:solidFill>
               </a:defRPr>
             </a:pPr>
-            <a:endParaRPr dirty="0"/>
-          </a:p>
-          <a:p>
-            <a:pPr>
-              <a:spcAft>
-                <a:spcPts val="800"/>
-              </a:spcAft>
-              <a:defRPr sz="1800">
-                <a:solidFill>
-                  <a:srgbClr val="1F2937"/>
-                </a:solidFill>
-              </a:defRPr>
-            </a:pPr>
-            <a:r>
-              <a:rPr dirty="0"/>
+          </a:p>
+          <a:p>
+            <a:pPr>
+              <a:spcAft>
+                <a:spcPts val="800"/>
+              </a:spcAft>
+              <a:defRPr sz="1800">
+                <a:solidFill>
+                  <a:srgbClr val="1F2937"/>
+                </a:solidFill>
+              </a:defRPr>
+            </a:pPr>
+            <a:r>
               <a:t>Q: What is the salary for the CEO?</a:t>
             </a:r>
           </a:p>
@@ -4002,7 +3947,6 @@
               </a:defRPr>
             </a:pPr>
             <a:r>
-              <a:rPr dirty="0"/>
               <a:t>A: I could not find this information in the available documents.</a:t>
             </a:r>
           </a:p>
@@ -4017,53 +3961,34 @@
                 </a:solidFill>
               </a:defRPr>
             </a:pPr>
-            <a:endParaRPr dirty="0"/>
-          </a:p>
-          <a:p>
-            <a:pPr>
-              <a:spcAft>
-                <a:spcPts val="800"/>
-              </a:spcAft>
-              <a:defRPr sz="1800">
-                <a:solidFill>
-                  <a:srgbClr val="1F2937"/>
-                </a:solidFill>
-              </a:defRPr>
-            </a:pPr>
-            <a:r>
-              <a:rPr dirty="0"/>
-              <a:t>Q: Hi, my name is </a:t>
-            </a:r>
-            <a:r>
-              <a:rPr lang="en-US" dirty="0" err="1" smtClean="0"/>
-              <a:t>vivek</a:t>
-            </a:r>
-            <a:r>
-              <a:rPr lang="en-US" dirty="0" smtClean="0"/>
-              <a:t> </a:t>
-            </a:r>
-            <a:r>
-              <a:rPr dirty="0" smtClean="0"/>
-              <a:t> </a:t>
-            </a:r>
-            <a:r>
-              <a:rPr dirty="0"/>
-              <a:t>from Bangalore.</a:t>
-            </a:r>
-          </a:p>
-          <a:p>
-            <a:pPr>
-              <a:spcAft>
-                <a:spcPts val="800"/>
-              </a:spcAft>
-              <a:defRPr sz="1800">
-                <a:solidFill>
-                  <a:srgbClr val="1F2937"/>
-                </a:solidFill>
-              </a:defRPr>
-            </a:pPr>
-            <a:r>
-              <a:rPr dirty="0"/>
+          </a:p>
+          <a:p>
+            <a:pPr>
+              <a:spcAft>
+                <a:spcPts val="800"/>
+              </a:spcAft>
+              <a:defRPr sz="1800">
+                <a:solidFill>
+                  <a:srgbClr val="1F2937"/>
+                </a:solidFill>
+              </a:defRPr>
+            </a:pPr>
+            <a:r>
+              <a:t>Q: Hi, my name is Abhishek from Bangalore.</a:t>
+            </a:r>
+          </a:p>
+          <a:p>
+            <a:pPr>
+              <a:spcAft>
+                <a:spcPts val="800"/>
+              </a:spcAft>
+              <a:defRPr sz="1800">
+                <a:solidFill>
+                  <a:srgbClr val="1F2937"/>
+                </a:solidFill>
+              </a:defRPr>
+            </a:pPr>
+            <a:r>
               <a:t>A: Brief acknowledgement without unsolicited policy advice.</a:t>
             </a:r>
           </a:p>
@@ -4078,7 +4003,7 @@
 </file>
 
 <file path=ppt/slides/slide14.xml><?xml version="1.0" encoding="utf-8"?>
-<p:sld xmlns:a="http://schemas.openxmlformats.org/drawingml/2006/main" xmlns:r="http://schemas.openxmlformats.org/officeDocument/2006/relationships" xmlns:p="http://schemas.openxmlformats.org/presentationml/2006/main">
+<p:sld xmlns:a="http://schemas.openxmlformats.org/drawingml/2006/main" xmlns:p="http://schemas.openxmlformats.org/presentationml/2006/main" xmlns:r="http://schemas.openxmlformats.org/officeDocument/2006/relationships">
   <p:cSld>
     <p:spTree>
       <p:nvGrpSpPr>
@@ -4086,14 +4011,7 @@
         <p:cNvGrpSpPr/>
         <p:nvPr/>
       </p:nvGrpSpPr>
-      <p:grpSpPr>
-        <a:xfrm>
-          <a:off x="0" y="0"/>
-          <a:ext cx="0" cy="0"/>
-          <a:chOff x="0" y="0"/>
-          <a:chExt cx="0" cy="0"/>
-        </a:xfrm>
-      </p:grpSpPr>
+      <p:grpSpPr/>
       <p:sp>
         <p:nvSpPr>
           <p:cNvPr id="2" name="TextBox 1"/>
@@ -4236,7 +4154,7 @@
 </file>
 
 <file path=ppt/slides/slide15.xml><?xml version="1.0" encoding="utf-8"?>
-<p:sld xmlns:a="http://schemas.openxmlformats.org/drawingml/2006/main" xmlns:r="http://schemas.openxmlformats.org/officeDocument/2006/relationships" xmlns:p="http://schemas.openxmlformats.org/presentationml/2006/main">
+<p:sld xmlns:a="http://schemas.openxmlformats.org/drawingml/2006/main" xmlns:p="http://schemas.openxmlformats.org/presentationml/2006/main" xmlns:r="http://schemas.openxmlformats.org/officeDocument/2006/relationships">
   <p:cSld>
     <p:spTree>
       <p:nvGrpSpPr>
@@ -4244,14 +4162,7 @@
         <p:cNvGrpSpPr/>
         <p:nvPr/>
       </p:nvGrpSpPr>
-      <p:grpSpPr>
-        <a:xfrm>
-          <a:off x="0" y="0"/>
-          <a:ext cx="0" cy="0"/>
-          <a:chOff x="0" y="0"/>
-          <a:chExt cx="0" cy="0"/>
-        </a:xfrm>
-      </p:grpSpPr>
+      <p:grpSpPr/>
       <p:sp>
         <p:nvSpPr>
           <p:cNvPr id="2" name="TextBox 1"/>
@@ -4282,7 +4193,7 @@
               </a:defRPr>
             </a:pPr>
             <a:r>
-              <a:t>How to Run</a:t>
+              <a:t>Limitations</a:t>
             </a:r>
           </a:p>
         </p:txBody>
@@ -4320,82 +4231,67 @@
               </a:defRPr>
             </a:pPr>
             <a:r>
-              <a:t>1. setup.bat (first time only)</a:t>
-            </a:r>
-          </a:p>
-          <a:p>
-            <a:pPr>
-              <a:spcAft>
-                <a:spcPts val="800"/>
-              </a:spcAft>
-              <a:defRPr sz="1800">
-                <a:solidFill>
-                  <a:srgbClr val="1F2937"/>
-                </a:solidFill>
-              </a:defRPr>
-            </a:pPr>
-            <a:r>
-              <a:t>2. copy .env.example .env and add OPENAI_API_KEY</a:t>
-            </a:r>
-          </a:p>
-          <a:p>
-            <a:pPr>
-              <a:spcAft>
-                <a:spcPts val="800"/>
-              </a:spcAft>
-              <a:defRPr sz="1800">
-                <a:solidFill>
-                  <a:srgbClr val="1F2937"/>
-                </a:solidFill>
-              </a:defRPr>
-            </a:pPr>
-            <a:r>
-              <a:t>3. python scripts/ingest.py</a:t>
-            </a:r>
-          </a:p>
-          <a:p>
-            <a:pPr>
-              <a:spcAft>
-                <a:spcPts val="800"/>
-              </a:spcAft>
-              <a:defRPr sz="1800">
-                <a:solidFill>
-                  <a:srgbClr val="1F2937"/>
-                </a:solidFill>
-              </a:defRPr>
-            </a:pPr>
-            <a:r>
-              <a:t>4. start.bat</a:t>
-            </a:r>
-          </a:p>
-          <a:p>
-            <a:pPr>
-              <a:spcAft>
-                <a:spcPts val="800"/>
-              </a:spcAft>
-              <a:defRPr sz="1800">
-                <a:solidFill>
-                  <a:srgbClr val="1F2937"/>
-                </a:solidFill>
-              </a:defRPr>
-            </a:pPr>
-            <a:r>
-              <a:t>5. Open http://localhost:8501</a:t>
-            </a:r>
-          </a:p>
-          <a:p>
-            <a:pPr>
-              <a:spcAft>
-                <a:spcPts val="800"/>
-              </a:spcAft>
-              <a:defRPr sz="1800">
-                <a:solidFill>
-                  <a:srgbClr val="1F2937"/>
-                </a:solidFill>
-              </a:defRPr>
-            </a:pPr>
-            <a:r>
-              <a:t>Submission docs available in SubmissionDocument/ folder.</a:t>
+              <a:t>Requires OpenAI API key (paid usage for embeddings and chat).</a:t>
+            </a:r>
+          </a:p>
+          <a:p>
+            <a:pPr>
+              <a:spcAft>
+                <a:spcPts val="800"/>
+              </a:spcAft>
+              <a:defRPr sz="1800">
+                <a:solidFill>
+                  <a:srgbClr val="1F2937"/>
+                </a:solidFill>
+              </a:defRPr>
+            </a:pPr>
+            <a:r>
+              <a:t>First startup may take 60–90 seconds while models load.</a:t>
+            </a:r>
+          </a:p>
+          <a:p>
+            <a:pPr>
+              <a:spcAft>
+                <a:spcPts val="800"/>
+              </a:spcAft>
+              <a:defRPr sz="1800">
+                <a:solidFill>
+                  <a:srgbClr val="1F2937"/>
+                </a:solidFill>
+              </a:defRPr>
+            </a:pPr>
+            <a:r>
+              <a:t>Answers limited to indexed documents only.</a:t>
+            </a:r>
+          </a:p>
+          <a:p>
+            <a:pPr>
+              <a:spcAft>
+                <a:spcPts val="800"/>
+              </a:spcAft>
+              <a:defRPr sz="1800">
+                <a:solidFill>
+                  <a:srgbClr val="1F2937"/>
+                </a:solidFill>
+              </a:defRPr>
+            </a:pPr>
+            <a:r>
+              <a:t>No user authentication or role-based access control.</a:t>
+            </a:r>
+          </a:p>
+          <a:p>
+            <a:pPr>
+              <a:spcAft>
+                <a:spcPts val="800"/>
+              </a:spcAft>
+              <a:defRPr sz="1800">
+                <a:solidFill>
+                  <a:srgbClr val="1F2937"/>
+                </a:solidFill>
+              </a:defRPr>
+            </a:pPr>
+            <a:r>
+              <a:t>Session-based memory (not persisted across server restarts).</a:t>
             </a:r>
           </a:p>
         </p:txBody>
@@ -4409,7 +4305,173 @@
 </file>
 
 <file path=ppt/slides/slide16.xml><?xml version="1.0" encoding="utf-8"?>
-<p:sld xmlns:a="http://schemas.openxmlformats.org/drawingml/2006/main" xmlns:r="http://schemas.openxmlformats.org/officeDocument/2006/relationships" xmlns:p="http://schemas.openxmlformats.org/presentationml/2006/main">
+<p:sld xmlns:a="http://schemas.openxmlformats.org/drawingml/2006/main" xmlns:p="http://schemas.openxmlformats.org/presentationml/2006/main" xmlns:r="http://schemas.openxmlformats.org/officeDocument/2006/relationships">
+  <p:cSld>
+    <p:spTree>
+      <p:nvGrpSpPr>
+        <p:cNvPr id="1" name=""/>
+        <p:cNvGrpSpPr/>
+        <p:nvPr/>
+      </p:nvGrpSpPr>
+      <p:grpSpPr/>
+      <p:sp>
+        <p:nvSpPr>
+          <p:cNvPr id="2" name="TextBox 1"/>
+          <p:cNvSpPr txBox="1"/>
+          <p:nvPr/>
+        </p:nvSpPr>
+        <p:spPr>
+          <a:xfrm>
+            <a:off x="457200" y="320040"/>
+            <a:ext cx="8229600" cy="731520"/>
+          </a:xfrm>
+          <a:prstGeom prst="rect">
+            <a:avLst/>
+          </a:prstGeom>
+          <a:noFill/>
+        </p:spPr>
+        <p:txBody>
+          <a:bodyPr wrap="none">
+            <a:spAutoFit/>
+          </a:bodyPr>
+          <a:lstStyle/>
+          <a:p>
+            <a:pPr>
+              <a:defRPr sz="3000" b="1">
+                <a:solidFill>
+                  <a:srgbClr val="1565C0"/>
+                </a:solidFill>
+              </a:defRPr>
+            </a:pPr>
+            <a:r>
+              <a:t>How to Run</a:t>
+            </a:r>
+          </a:p>
+        </p:txBody>
+      </p:sp>
+      <p:sp>
+        <p:nvSpPr>
+          <p:cNvPr id="3" name="TextBox 2"/>
+          <p:cNvSpPr txBox="1"/>
+          <p:nvPr/>
+        </p:nvSpPr>
+        <p:spPr>
+          <a:xfrm>
+            <a:off x="640080" y="1097280"/>
+            <a:ext cx="8046720" cy="5303520"/>
+          </a:xfrm>
+          <a:prstGeom prst="rect">
+            <a:avLst/>
+          </a:prstGeom>
+          <a:noFill/>
+        </p:spPr>
+        <p:txBody>
+          <a:bodyPr wrap="none">
+            <a:spAutoFit/>
+          </a:bodyPr>
+          <a:lstStyle/>
+          <a:p>
+            <a:pPr>
+              <a:spcAft>
+                <a:spcPts val="800"/>
+              </a:spcAft>
+              <a:defRPr sz="1800">
+                <a:solidFill>
+                  <a:srgbClr val="1F2937"/>
+                </a:solidFill>
+              </a:defRPr>
+            </a:pPr>
+            <a:r>
+              <a:t>1. setup.bat (first time only)</a:t>
+            </a:r>
+          </a:p>
+          <a:p>
+            <a:pPr>
+              <a:spcAft>
+                <a:spcPts val="800"/>
+              </a:spcAft>
+              <a:defRPr sz="1800">
+                <a:solidFill>
+                  <a:srgbClr val="1F2937"/>
+                </a:solidFill>
+              </a:defRPr>
+            </a:pPr>
+            <a:r>
+              <a:t>2. copy .env.example .env and add OPENAI_API_KEY</a:t>
+            </a:r>
+          </a:p>
+          <a:p>
+            <a:pPr>
+              <a:spcAft>
+                <a:spcPts val="800"/>
+              </a:spcAft>
+              <a:defRPr sz="1800">
+                <a:solidFill>
+                  <a:srgbClr val="1F2937"/>
+                </a:solidFill>
+              </a:defRPr>
+            </a:pPr>
+            <a:r>
+              <a:t>3. python scripts/ingest.py</a:t>
+            </a:r>
+          </a:p>
+          <a:p>
+            <a:pPr>
+              <a:spcAft>
+                <a:spcPts val="800"/>
+              </a:spcAft>
+              <a:defRPr sz="1800">
+                <a:solidFill>
+                  <a:srgbClr val="1F2937"/>
+                </a:solidFill>
+              </a:defRPr>
+            </a:pPr>
+            <a:r>
+              <a:t>4. start.bat</a:t>
+            </a:r>
+          </a:p>
+          <a:p>
+            <a:pPr>
+              <a:spcAft>
+                <a:spcPts val="800"/>
+              </a:spcAft>
+              <a:defRPr sz="1800">
+                <a:solidFill>
+                  <a:srgbClr val="1F2937"/>
+                </a:solidFill>
+              </a:defRPr>
+            </a:pPr>
+            <a:r>
+              <a:t>5. Open http://localhost:8501</a:t>
+            </a:r>
+          </a:p>
+          <a:p>
+            <a:pPr>
+              <a:spcAft>
+                <a:spcPts val="800"/>
+              </a:spcAft>
+              <a:defRPr sz="1800">
+                <a:solidFill>
+                  <a:srgbClr val="1F2937"/>
+                </a:solidFill>
+              </a:defRPr>
+            </a:pPr>
+            <a:r>
+              <a:t>Submission docs available in SubmissionDocument/ folder.</a:t>
+            </a:r>
+          </a:p>
+        </p:txBody>
+      </p:sp>
+    </p:spTree>
+  </p:cSld>
+  <p:clrMapOvr>
+    <a:masterClrMapping/>
+  </p:clrMapOvr>
+</p:sld>
+</file>
+
+<file path=ppt/slides/slide17.xml><?xml version="1.0" encoding="utf-8"?>
+<p:sld xmlns:a="http://schemas.openxmlformats.org/drawingml/2006/main" xmlns:p="http://schemas.openxmlformats.org/presentationml/2006/main" xmlns:r="http://schemas.openxmlformats.org/officeDocument/2006/relationships">
   <p:cSld>
     <p:bg>
       <p:bgPr>
@@ -4425,14 +4487,7 @@
         <p:cNvGrpSpPr/>
         <p:nvPr/>
       </p:nvGrpSpPr>
-      <p:grpSpPr>
-        <a:xfrm>
-          <a:off x="0" y="0"/>
-          <a:ext cx="0" cy="0"/>
-          <a:chOff x="0" y="0"/>
-          <a:chExt cx="0" cy="0"/>
-        </a:xfrm>
-      </p:grpSpPr>
+      <p:grpSpPr/>
       <p:sp>
         <p:nvSpPr>
           <p:cNvPr id="2" name="TextBox 1"/>
@@ -4501,9 +4556,7 @@
               <a:t>Questions &amp; Discussion</a:t>
             </a:r>
           </a:p>
-          <a:p>
-            <a:endParaRPr/>
-          </a:p>
+          <a:p/>
           <a:p>
             <a:r>
               <a:t>Vivek Kumar</a:t>
@@ -4525,7 +4578,7 @@
 </file>
 
 <file path=ppt/slides/slide2.xml><?xml version="1.0" encoding="utf-8"?>
-<p:sld xmlns:a="http://schemas.openxmlformats.org/drawingml/2006/main" xmlns:r="http://schemas.openxmlformats.org/officeDocument/2006/relationships" xmlns:p="http://schemas.openxmlformats.org/presentationml/2006/main">
+<p:sld xmlns:a="http://schemas.openxmlformats.org/drawingml/2006/main" xmlns:p="http://schemas.openxmlformats.org/presentationml/2006/main" xmlns:r="http://schemas.openxmlformats.org/officeDocument/2006/relationships">
   <p:cSld>
     <p:spTree>
       <p:nvGrpSpPr>
@@ -4533,14 +4586,7 @@
         <p:cNvGrpSpPr/>
         <p:nvPr/>
       </p:nvGrpSpPr>
-      <p:grpSpPr>
-        <a:xfrm>
-          <a:off x="0" y="0"/>
-          <a:ext cx="0" cy="0"/>
-          <a:chOff x="0" y="0"/>
-          <a:chExt cx="0" cy="0"/>
-        </a:xfrm>
-      </p:grpSpPr>
+      <p:grpSpPr/>
       <p:sp>
         <p:nvSpPr>
           <p:cNvPr id="2" name="TextBox 1"/>
@@ -4668,7 +4714,7 @@
 </file>
 
 <file path=ppt/slides/slide3.xml><?xml version="1.0" encoding="utf-8"?>
-<p:sld xmlns:a="http://schemas.openxmlformats.org/drawingml/2006/main" xmlns:r="http://schemas.openxmlformats.org/officeDocument/2006/relationships" xmlns:p="http://schemas.openxmlformats.org/presentationml/2006/main">
+<p:sld xmlns:a="http://schemas.openxmlformats.org/drawingml/2006/main" xmlns:p="http://schemas.openxmlformats.org/presentationml/2006/main" xmlns:r="http://schemas.openxmlformats.org/officeDocument/2006/relationships">
   <p:cSld>
     <p:spTree>
       <p:nvGrpSpPr>
@@ -4676,14 +4722,7 @@
         <p:cNvGrpSpPr/>
         <p:nvPr/>
       </p:nvGrpSpPr>
-      <p:grpSpPr>
-        <a:xfrm>
-          <a:off x="0" y="0"/>
-          <a:ext cx="0" cy="0"/>
-          <a:chOff x="0" y="0"/>
-          <a:chExt cx="0" cy="0"/>
-        </a:xfrm>
-      </p:grpSpPr>
+      <p:grpSpPr/>
       <p:sp>
         <p:nvSpPr>
           <p:cNvPr id="2" name="TextBox 1"/>
@@ -4826,7 +4865,7 @@
 </file>
 
 <file path=ppt/slides/slide4.xml><?xml version="1.0" encoding="utf-8"?>
-<p:sld xmlns:a="http://schemas.openxmlformats.org/drawingml/2006/main" xmlns:r="http://schemas.openxmlformats.org/officeDocument/2006/relationships" xmlns:p="http://schemas.openxmlformats.org/presentationml/2006/main">
+<p:sld xmlns:a="http://schemas.openxmlformats.org/drawingml/2006/main" xmlns:p="http://schemas.openxmlformats.org/presentationml/2006/main" xmlns:r="http://schemas.openxmlformats.org/officeDocument/2006/relationships">
   <p:cSld>
     <p:spTree>
       <p:nvGrpSpPr>
@@ -4834,14 +4873,7 @@
         <p:cNvGrpSpPr/>
         <p:nvPr/>
       </p:nvGrpSpPr>
-      <p:grpSpPr>
-        <a:xfrm>
-          <a:off x="0" y="0"/>
-          <a:ext cx="0" cy="0"/>
-          <a:chOff x="0" y="0"/>
-          <a:chExt cx="0" cy="0"/>
-        </a:xfrm>
-      </p:grpSpPr>
+      <p:grpSpPr/>
       <p:sp>
         <p:nvSpPr>
           <p:cNvPr id="2" name="TextBox 1"/>
@@ -4894,7 +4926,7 @@
         <p:spPr>
           <a:xfrm>
             <a:off x="320040" y="777240"/>
-            <a:ext cx="8503920" cy="5663744"/>
+            <a:ext cx="8503920" cy="6720840"/>
           </a:xfrm>
           <a:prstGeom prst="rect">
             <a:avLst/>
@@ -4945,7 +4977,7 @@
 </file>
 
 <file path=ppt/slides/slide5.xml><?xml version="1.0" encoding="utf-8"?>
-<p:sld xmlns:a="http://schemas.openxmlformats.org/drawingml/2006/main" xmlns:r="http://schemas.openxmlformats.org/officeDocument/2006/relationships" xmlns:p="http://schemas.openxmlformats.org/presentationml/2006/main">
+<p:sld xmlns:a="http://schemas.openxmlformats.org/drawingml/2006/main" xmlns:p="http://schemas.openxmlformats.org/presentationml/2006/main" xmlns:r="http://schemas.openxmlformats.org/officeDocument/2006/relationships">
   <p:cSld>
     <p:spTree>
       <p:nvGrpSpPr>
@@ -4953,14 +4985,7 @@
         <p:cNvGrpSpPr/>
         <p:nvPr/>
       </p:nvGrpSpPr>
-      <p:grpSpPr>
-        <a:xfrm>
-          <a:off x="0" y="0"/>
-          <a:ext cx="0" cy="0"/>
-          <a:chOff x="0" y="0"/>
-          <a:chExt cx="0" cy="0"/>
-        </a:xfrm>
-      </p:grpSpPr>
+      <p:grpSpPr/>
       <p:sp>
         <p:nvSpPr>
           <p:cNvPr id="2" name="TextBox 1"/>
@@ -5850,6 +5875,101 @@
               </a:defRPr>
             </a:pPr>
             <a:r>
+              <a:t>            +-----------+-----------+</a:t>
+            </a:r>
+          </a:p>
+          <a:p>
+            <a:pPr>
+              <a:lnSpc>
+                <a:spcPct val="100000"/>
+              </a:lnSpc>
+              <a:spcAft>
+                <a:spcPts val="0"/>
+              </a:spcAft>
+              <a:defRPr sz="750">
+                <a:solidFill>
+                  <a:srgbClr val="1F2937"/>
+                </a:solidFill>
+                <a:latin typeface="Courier New"/>
+              </a:defRPr>
+            </a:pPr>
+            <a:r>
+              <a:t>                        v</a:t>
+            </a:r>
+          </a:p>
+          <a:p>
+            <a:pPr>
+              <a:lnSpc>
+                <a:spcPct val="100000"/>
+              </a:lnSpc>
+              <a:spcAft>
+                <a:spcPts val="0"/>
+              </a:spcAft>
+              <a:defRPr sz="750">
+                <a:solidFill>
+                  <a:srgbClr val="1F2937"/>
+                </a:solidFill>
+                <a:latin typeface="Courier New"/>
+              </a:defRPr>
+            </a:pPr>
+            <a:r>
+              <a:t>            +-----------------------+</a:t>
+            </a:r>
+          </a:p>
+          <a:p>
+            <a:pPr>
+              <a:lnSpc>
+                <a:spcPct val="100000"/>
+              </a:lnSpc>
+              <a:spcAft>
+                <a:spcPts val="0"/>
+              </a:spcAft>
+              <a:defRPr sz="750">
+                <a:solidFill>
+                  <a:srgbClr val="1F2937"/>
+                </a:solidFill>
+                <a:latin typeface="Courier New"/>
+              </a:defRPr>
+            </a:pPr>
+            <a:r>
+              <a:t>            |   Session Logger      |  util/logger.py</a:t>
+            </a:r>
+          </a:p>
+          <a:p>
+            <a:pPr>
+              <a:lnSpc>
+                <a:spcPct val="100000"/>
+              </a:lnSpc>
+              <a:spcAft>
+                <a:spcPts val="0"/>
+              </a:spcAft>
+              <a:defRPr sz="750">
+                <a:solidFill>
+                  <a:srgbClr val="1F2937"/>
+                </a:solidFill>
+                <a:latin typeface="Courier New"/>
+              </a:defRPr>
+            </a:pPr>
+            <a:r>
+              <a:t>            |  (cross-cutting)        |  -&gt; logs/</a:t>
+            </a:r>
+          </a:p>
+          <a:p>
+            <a:pPr>
+              <a:lnSpc>
+                <a:spcPct val="100000"/>
+              </a:lnSpc>
+              <a:spcAft>
+                <a:spcPts val="0"/>
+              </a:spcAft>
+              <a:defRPr sz="750">
+                <a:solidFill>
+                  <a:srgbClr val="1F2937"/>
+                </a:solidFill>
+                <a:latin typeface="Courier New"/>
+              </a:defRPr>
+            </a:pPr>
+            <a:r>
               <a:t>            +-----------------------+</a:t>
             </a:r>
           </a:p>
@@ -5864,7 +5984,7 @@
 </file>
 
 <file path=ppt/slides/slide6.xml><?xml version="1.0" encoding="utf-8"?>
-<p:sld xmlns:a="http://schemas.openxmlformats.org/drawingml/2006/main" xmlns:r="http://schemas.openxmlformats.org/officeDocument/2006/relationships" xmlns:p="http://schemas.openxmlformats.org/presentationml/2006/main">
+<p:sld xmlns:a="http://schemas.openxmlformats.org/drawingml/2006/main" xmlns:p="http://schemas.openxmlformats.org/presentationml/2006/main" xmlns:r="http://schemas.openxmlformats.org/officeDocument/2006/relationships">
   <p:cSld>
     <p:spTree>
       <p:nvGrpSpPr>
@@ -5872,14 +5992,7 @@
         <p:cNvGrpSpPr/>
         <p:nvPr/>
       </p:nvGrpSpPr>
-      <p:grpSpPr>
-        <a:xfrm>
-          <a:off x="0" y="0"/>
-          <a:ext cx="0" cy="0"/>
-          <a:chOff x="0" y="0"/>
-          <a:chExt cx="0" cy="0"/>
-        </a:xfrm>
-      </p:grpSpPr>
+      <p:grpSpPr/>
       <p:sp>
         <p:nvSpPr>
           <p:cNvPr id="2" name="TextBox 1"/>
@@ -5923,8 +6036,8 @@
         </p:nvSpPr>
         <p:spPr>
           <a:xfrm>
-            <a:off x="640081" y="1097280"/>
-            <a:ext cx="8214670" cy="3477875"/>
+            <a:off x="640080" y="1097280"/>
+            <a:ext cx="8046720" cy="5303520"/>
           </a:xfrm>
           <a:prstGeom prst="rect">
             <a:avLst/>
@@ -5932,7 +6045,7 @@
           <a:noFill/>
         </p:spPr>
         <p:txBody>
-          <a:bodyPr wrap="square">
+          <a:bodyPr wrap="none">
             <a:spAutoFit/>
           </a:bodyPr>
           <a:lstStyle/>
@@ -5948,92 +6061,36 @@
               </a:defRPr>
             </a:pPr>
             <a:r>
-              <a:rPr dirty="0"/>
-              <a:t>Indexing: Documents → Loader → </a:t>
-            </a:r>
-            <a:r>
-              <a:rPr dirty="0" err="1"/>
-              <a:t>Chunker</a:t>
-            </a:r>
-            <a:r>
-              <a:rPr dirty="0"/>
-              <a:t> → </a:t>
-            </a:r>
-            <a:r>
-              <a:rPr dirty="0" err="1"/>
-              <a:t>Embeddings</a:t>
-            </a:r>
-            <a:r>
-              <a:rPr dirty="0"/>
-              <a:t> → </a:t>
-            </a:r>
-            <a:r>
-              <a:rPr dirty="0" err="1"/>
-              <a:t>ChromaDB</a:t>
-            </a:r>
-            <a:r>
-              <a:rPr dirty="0"/>
-              <a:t> + BM25.</a:t>
-            </a:r>
-          </a:p>
-          <a:p>
-            <a:pPr>
-              <a:spcAft>
-                <a:spcPts val="800"/>
-              </a:spcAft>
-              <a:defRPr sz="1800">
-                <a:solidFill>
-                  <a:srgbClr val="1F2937"/>
-                </a:solidFill>
-              </a:defRPr>
-            </a:pPr>
-            <a:r>
-              <a:rPr dirty="0"/>
-              <a:t>Query: </a:t>
-            </a:r>
-            <a:endParaRPr lang="en-US" dirty="0" smtClean="0"/>
-          </a:p>
-          <a:p>
-            <a:pPr>
-              <a:spcAft>
-                <a:spcPts val="800"/>
-              </a:spcAft>
-              <a:defRPr sz="1800">
-                <a:solidFill>
-                  <a:srgbClr val="1F2937"/>
-                </a:solidFill>
-              </a:defRPr>
-            </a:pPr>
-            <a:r>
-              <a:rPr dirty="0" smtClean="0"/>
-              <a:t>User </a:t>
-            </a:r>
-            <a:r>
-              <a:rPr dirty="0"/>
-              <a:t>input → route → memory rewrite → hybrid search → </a:t>
-            </a:r>
-            <a:r>
-              <a:rPr dirty="0" err="1"/>
-              <a:t>rerank</a:t>
-            </a:r>
-            <a:r>
-              <a:rPr dirty="0"/>
-              <a:t> → context builder → LLM.</a:t>
-            </a:r>
-          </a:p>
-          <a:p>
-            <a:pPr>
-              <a:spcAft>
-                <a:spcPts val="800"/>
-              </a:spcAft>
-              <a:defRPr sz="1800">
-                <a:solidFill>
-                  <a:srgbClr val="1F2937"/>
-                </a:solidFill>
-              </a:defRPr>
-            </a:pPr>
-            <a:r>
-              <a:rPr dirty="0"/>
+              <a:t>Indexing: Documents → Loader → Chunker → Embeddings → ChromaDB + BM25.</a:t>
+            </a:r>
+          </a:p>
+          <a:p>
+            <a:pPr>
+              <a:spcAft>
+                <a:spcPts val="800"/>
+              </a:spcAft>
+              <a:defRPr sz="1800">
+                <a:solidFill>
+                  <a:srgbClr val="1F2937"/>
+                </a:solidFill>
+              </a:defRPr>
+            </a:pPr>
+            <a:r>
+              <a:t>Query: User input → route → memory rewrite → hybrid search → rerank → context builder → LLM.</a:t>
+            </a:r>
+          </a:p>
+          <a:p>
+            <a:pPr>
+              <a:spcAft>
+                <a:spcPts val="800"/>
+              </a:spcAft>
+              <a:defRPr sz="1800">
+                <a:solidFill>
+                  <a:srgbClr val="1F2937"/>
+                </a:solidFill>
+              </a:defRPr>
+            </a:pPr>
+            <a:r>
               <a:t>Routing: greetings (UI); casual intros and memory questions get instant replies without retrieval.</a:t>
             </a:r>
           </a:p>
@@ -6049,23 +6106,21 @@
               </a:defRPr>
             </a:pPr>
             <a:r>
-              <a:rPr dirty="0"/>
-              <a:t>Policy questions run the full RAG pipeline and return answers with source citations.</a:t>
-            </a:r>
-          </a:p>
-          <a:p>
-            <a:pPr>
-              <a:spcAft>
-                <a:spcPts val="800"/>
-              </a:spcAft>
-              <a:defRPr sz="1800">
-                <a:solidFill>
-                  <a:srgbClr val="1F2937"/>
-                </a:solidFill>
-              </a:defRPr>
-            </a:pPr>
-            <a:r>
-              <a:rPr dirty="0"/>
+              <a:t>Policy questions run the full RAG pipeline and return grounded answers.</a:t>
+            </a:r>
+          </a:p>
+          <a:p>
+            <a:pPr>
+              <a:spcAft>
+                <a:spcPts val="800"/>
+              </a:spcAft>
+              <a:defRPr sz="1800">
+                <a:solidFill>
+                  <a:srgbClr val="1F2937"/>
+                </a:solidFill>
+              </a:defRPr>
+            </a:pPr>
+            <a:r>
               <a:t>Hallucination guard returns a safe not-found message when no relevant chunks are found.</a:t>
             </a:r>
           </a:p>
@@ -6081,12 +6136,22 @@
               </a:defRPr>
             </a:pPr>
             <a:r>
-              <a:rPr dirty="0" err="1"/>
-              <a:t>Streamlit</a:t>
-            </a:r>
-            <a:r>
-              <a:rPr dirty="0"/>
-              <a:t> UI shows chat history, sources, Knowledge Scope filter, and Clear/Reset.</a:t>
+              <a:t>Session logger (util/logger.py) records all pipeline steps, retrieval, and LLM I/O to logs/.</a:t>
+            </a:r>
+          </a:p>
+          <a:p>
+            <a:pPr>
+              <a:spcAft>
+                <a:spcPts val="800"/>
+              </a:spcAft>
+              <a:defRPr sz="1800">
+                <a:solidFill>
+                  <a:srgbClr val="1F2937"/>
+                </a:solidFill>
+              </a:defRPr>
+            </a:pPr>
+            <a:r>
+              <a:t>Streamlit UI shows chat history, Knowledge Scope filter, and Clear/Reset.</a:t>
             </a:r>
           </a:p>
         </p:txBody>
@@ -6100,7 +6165,7 @@
 </file>
 
 <file path=ppt/slides/slide7.xml><?xml version="1.0" encoding="utf-8"?>
-<p:sld xmlns:a="http://schemas.openxmlformats.org/drawingml/2006/main" xmlns:r="http://schemas.openxmlformats.org/officeDocument/2006/relationships" xmlns:p="http://schemas.openxmlformats.org/presentationml/2006/main">
+<p:sld xmlns:a="http://schemas.openxmlformats.org/drawingml/2006/main" xmlns:p="http://schemas.openxmlformats.org/presentationml/2006/main" xmlns:r="http://schemas.openxmlformats.org/officeDocument/2006/relationships">
   <p:cSld>
     <p:spTree>
       <p:nvGrpSpPr>
@@ -6108,14 +6173,7 @@
         <p:cNvGrpSpPr/>
         <p:nvPr/>
       </p:nvGrpSpPr>
-      <p:grpSpPr>
-        <a:xfrm>
-          <a:off x="0" y="0"/>
-          <a:ext cx="0" cy="0"/>
-          <a:chOff x="0" y="0"/>
-          <a:chExt cx="0" cy="0"/>
-        </a:xfrm>
-      </p:grpSpPr>
+      <p:grpSpPr/>
       <p:sp>
         <p:nvSpPr>
           <p:cNvPr id="2" name="TextBox 1"/>
@@ -6303,7 +6361,7 @@
 </file>
 
 <file path=ppt/slides/slide8.xml><?xml version="1.0" encoding="utf-8"?>
-<p:sld xmlns:a="http://schemas.openxmlformats.org/drawingml/2006/main" xmlns:r="http://schemas.openxmlformats.org/officeDocument/2006/relationships" xmlns:p="http://schemas.openxmlformats.org/presentationml/2006/main">
+<p:sld xmlns:a="http://schemas.openxmlformats.org/drawingml/2006/main" xmlns:p="http://schemas.openxmlformats.org/presentationml/2006/main" xmlns:r="http://schemas.openxmlformats.org/officeDocument/2006/relationships">
   <p:cSld>
     <p:spTree>
       <p:nvGrpSpPr>
@@ -6311,14 +6369,7 @@
         <p:cNvGrpSpPr/>
         <p:nvPr/>
       </p:nvGrpSpPr>
-      <p:grpSpPr>
-        <a:xfrm>
-          <a:off x="0" y="0"/>
-          <a:ext cx="0" cy="0"/>
-          <a:chOff x="0" y="0"/>
-          <a:chExt cx="0" cy="0"/>
-        </a:xfrm>
-      </p:grpSpPr>
+      <p:grpSpPr/>
       <p:sp>
         <p:nvSpPr>
           <p:cNvPr id="2" name="TextBox 1"/>
@@ -6506,7 +6557,7 @@
 </file>
 
 <file path=ppt/slides/slide9.xml><?xml version="1.0" encoding="utf-8"?>
-<p:sld xmlns:a="http://schemas.openxmlformats.org/drawingml/2006/main" xmlns:r="http://schemas.openxmlformats.org/officeDocument/2006/relationships" xmlns:p="http://schemas.openxmlformats.org/presentationml/2006/main">
+<p:sld xmlns:a="http://schemas.openxmlformats.org/drawingml/2006/main" xmlns:p="http://schemas.openxmlformats.org/presentationml/2006/main" xmlns:r="http://schemas.openxmlformats.org/officeDocument/2006/relationships">
   <p:cSld>
     <p:spTree>
       <p:nvGrpSpPr>
@@ -6514,14 +6565,7 @@
         <p:cNvGrpSpPr/>
         <p:nvPr/>
       </p:nvGrpSpPr>
-      <p:grpSpPr>
-        <a:xfrm>
-          <a:off x="0" y="0"/>
-          <a:ext cx="0" cy="0"/>
-          <a:chOff x="0" y="0"/>
-          <a:chExt cx="0" cy="0"/>
-        </a:xfrm>
-      </p:grpSpPr>
+      <p:grpSpPr/>
       <p:sp>
         <p:nvSpPr>
           <p:cNvPr id="2" name="TextBox 1"/>

</xml_diff>